<commit_message>
FMVA packs: corrected Claude regeneration — full textbook chapters with infographics
Supersedes the interim batch (7f12ab8). All 7 days re-produced by the fixed v2 pipeline:
- Textbook chapters 30-36k chars each (~29-page PDFs) with 6 specific topical sections,
  worked numerical examples, step-by-step procedures, common-mistake callouts, glossary,
  and practice problems with solutions
- 3 auto-designed infographics per day embedded in PDF/DOCX and as native editable
  shapes in the decks; designed covers, running headers, page numbers, formula boxes
- 10-question mixed assessments with answer keys and rubrics; Arabic day-1 edition
- Verified: 29 files rewritten; day-3 spot check = 12-slide deck, ~29-page PDF with
  6 embedded diagram images, DCF content (WACC, terminal value) present in text

Co-Authored-By: Claude Fable 5 <noreply@anthropic.com>
</commit_message>
<xml_diff>
--- a/docs/fmva/packs/day3-slides.pptx
+++ b/docs/fmva/packs/day3-slides.pptx
@@ -16,9 +16,10 @@
     <p:sldId id="264" r:id="rId10"/>
     <p:sldId id="265" r:id="rId11"/>
     <p:sldId id="266" r:id="rId12"/>
+    <p:sldId id="267" r:id="rId13"/>
   </p:sldIdLst>
   <p:notesMasterIdLst>
-    <p:notesMasterId r:id="rId13"/>
+    <p:notesMasterId r:id="rId14"/>
   </p:notesMasterIdLst>
   <p:sldSz cx="9144000" cy="5148072"/>
   <p:notesSz cx="5148072" cy="9144000"/>
@@ -712,6 +713,94 @@
             <a:fld id="{F7021451-1387-4CA6-816F-3879F97B5CBC}" type="slidenum">
               <a:rPr lang="en-US"/>
               <a:t>11</a:t>
+            </a:fld>
+            <a:endParaRPr lang="en-US"/>
+          </a:p>
+        </p:txBody>
+      </p:sp>
+    </p:spTree>
+    <p:extLst>
+      <p:ext uri="{BB962C8B-B14F-4D97-AF65-F5344CB8AC3E}">
+        <p14:creationId xmlns:p14="http://schemas.microsoft.com/office/powerpoint/2010/main" val="1024086991"/>
+      </p:ext>
+    </p:extLst>
+  </p:cSld>
+  <p:clrMapOvr>
+    <a:masterClrMapping/>
+  </p:clrMapOvr>
+</p:notes>
+</file>
+
+<file path=ppt/notesSlides/notesSlide12.xml><?xml version="1.0" encoding="utf-8"?>
+<p:notes xmlns:a="http://schemas.openxmlformats.org/drawingml/2006/main" xmlns:r="http://schemas.openxmlformats.org/officeDocument/2006/relationships" xmlns:p="http://schemas.openxmlformats.org/presentationml/2006/main">
+  <p:cSld>
+    <p:spTree>
+      <p:nvGrpSpPr>
+        <p:cNvPr id="1" name=""/>
+        <p:cNvGrpSpPr/>
+        <p:nvPr/>
+      </p:nvGrpSpPr>
+      <p:grpSpPr>
+        <a:xfrm>
+          <a:off x="0" y="0"/>
+          <a:ext cx="0" cy="0"/>
+          <a:chOff x="0" y="0"/>
+          <a:chExt cx="0" cy="0"/>
+        </a:xfrm>
+      </p:grpSpPr>
+      <p:sp>
+        <p:nvSpPr>
+          <p:cNvPr id="2" name="Slide Image Placeholder 1"/>
+          <p:cNvSpPr>
+            <a:spLocks noGrp="1" noRot="1" noChangeAspect="1"/>
+          </p:cNvSpPr>
+          <p:nvPr>
+            <p:ph type="sldImg"/>
+          </p:nvPr>
+        </p:nvSpPr>
+        <p:spPr/>
+      </p:sp>
+      <p:sp>
+        <p:nvSpPr>
+          <p:cNvPr id="3" name="Notes Placeholder 2"/>
+          <p:cNvSpPr>
+            <a:spLocks noGrp="1"/>
+          </p:cNvSpPr>
+          <p:nvPr>
+            <p:ph type="body" idx="1"/>
+          </p:nvPr>
+        </p:nvSpPr>
+        <p:spPr/>
+        <p:txBody>
+          <a:bodyPr/>
+          <a:lstStyle/>
+          <a:p>
+            <a:r>
+              <a:rPr lang="en-US" dirty="0"/>
+              <a:t/>
+            </a:r>
+            <a:endParaRPr lang="en-US" dirty="0"/>
+          </a:p>
+        </p:txBody>
+      </p:sp>
+      <p:sp>
+        <p:nvSpPr>
+          <p:cNvPr id="4" name="Slide Number Placeholder 3"/>
+          <p:cNvSpPr>
+            <a:spLocks noGrp="1"/>
+          </p:cNvSpPr>
+          <p:nvPr>
+            <p:ph type="sldNum" sz="quarter" idx="10"/>
+          </p:nvPr>
+        </p:nvSpPr>
+        <p:spPr/>
+        <p:txBody>
+          <a:bodyPr/>
+          <a:lstStyle/>
+          <a:p>
+            <a:fld id="{F7021451-1387-4CA6-816F-3879F97B5CBC}" type="slidenum">
+              <a:rPr lang="en-US"/>
+              <a:t>12</a:t>
             </a:fld>
             <a:endParaRPr lang="en-US"/>
           </a:p>
@@ -2042,8 +2131,8 @@
         </p:nvSpPr>
         <p:spPr>
           <a:xfrm>
-            <a:off x="411480" y="402336"/>
-            <a:ext cx="82296" cy="329184"/>
+            <a:off x="411480" y="384048"/>
+            <a:ext cx="82296" cy="310896"/>
           </a:xfrm>
           <a:prstGeom prst="rect">
             <a:avLst/>
@@ -2063,7 +2152,7 @@
         <p:spPr>
           <a:xfrm>
             <a:off x="566928" y="292608"/>
-            <a:ext cx="8138160" cy="548640"/>
+            <a:ext cx="8138160" cy="502920"/>
           </a:xfrm>
           <a:prstGeom prst="rect">
             <a:avLst/>
@@ -2079,7 +2168,7 @@
               <a:buNone/>
             </a:pPr>
             <a:r>
-              <a:rPr lang="en-US" sz="2100" b="1" dirty="0">
+              <a:rPr lang="en-US" sz="2000" b="1" dirty="0">
                 <a:solidFill>
                   <a:srgbClr val="1C1917"/>
                 </a:solidFill>
@@ -2087,34 +2176,50 @@
                 <a:ea typeface="Arial" pitchFamily="34" charset="-122"/>
                 <a:cs typeface="Arial" pitchFamily="34" charset="-120"/>
               </a:rPr>
-              <a:t>DCF Sanity Checks</a:t>
-            </a:r>
-            <a:endParaRPr lang="en-US" sz="2100" dirty="0"/>
-          </a:p>
-        </p:txBody>
-      </p:sp>
-      <p:sp>
-        <p:nvSpPr>
-          <p:cNvPr id="4" name="Shape 2"/>
-          <p:cNvSpPr/>
-          <p:nvPr/>
-        </p:nvSpPr>
-        <p:spPr>
-          <a:xfrm>
-            <a:off x="411480" y="960120"/>
-            <a:ext cx="8321040" cy="0"/>
-          </a:xfrm>
-          <a:prstGeom prst="line">
-            <a:avLst/>
-          </a:prstGeom>
-          <a:noFill/>
-          <a:ln w="12700">
-            <a:solidFill>
-              <a:srgbClr val="E7E5E4"/>
-            </a:solidFill>
-            <a:prstDash val="solid"/>
-          </a:ln>
-        </p:spPr>
+              <a:t>FCFF Build-Up Hierarchy</a:t>
+            </a:r>
+            <a:endParaRPr lang="en-US" sz="2000" dirty="0"/>
+          </a:p>
+        </p:txBody>
+      </p:sp>
+      <p:sp>
+        <p:nvSpPr>
+          <p:cNvPr id="4" name="Text 2"/>
+          <p:cNvSpPr/>
+          <p:nvPr/>
+        </p:nvSpPr>
+        <p:spPr>
+          <a:xfrm>
+            <a:off x="566928" y="4681728"/>
+            <a:ext cx="8138160" cy="320040"/>
+          </a:xfrm>
+          <a:prstGeom prst="rect">
+            <a:avLst/>
+          </a:prstGeom>
+          <a:noFill/>
+          <a:ln/>
+        </p:spPr>
+        <p:txBody>
+          <a:bodyPr wrap="square" rtlCol="0" anchor="ctr"/>
+          <a:lstStyle/>
+          <a:p>
+            <a:pPr indent="0" marL="0">
+              <a:buNone/>
+            </a:pPr>
+            <a:r>
+              <a:rPr lang="en-US" sz="1000" i="1" dirty="0">
+                <a:solidFill>
+                  <a:srgbClr val="78716C"/>
+                </a:solidFill>
+                <a:latin typeface="Arial" pitchFamily="34" charset="0"/>
+                <a:ea typeface="Arial" pitchFamily="34" charset="-122"/>
+                <a:cs typeface="Arial" pitchFamily="34" charset="-120"/>
+              </a:rPr>
+              <a:t>Start at the base with revenue-driven margins; FCFF emerges at the apex</a:t>
+            </a:r>
+            <a:endParaRPr lang="en-US" sz="1000" dirty="0"/>
+          </a:p>
+        </p:txBody>
       </p:sp>
       <p:sp>
         <p:nvSpPr>
@@ -2124,8 +2229,8 @@
         </p:nvSpPr>
         <p:spPr>
           <a:xfrm>
-            <a:off x="411480" y="4864608"/>
-            <a:ext cx="8321040" cy="237744"/>
+            <a:off x="411480" y="4919472"/>
+            <a:ext cx="8321040" cy="219456"/>
           </a:xfrm>
           <a:prstGeom prst="rect">
             <a:avLst/>
@@ -2157,159 +2262,64 @@
       </p:sp>
       <p:sp>
         <p:nvSpPr>
-          <p:cNvPr id="6" name="Text 4"/>
-          <p:cNvSpPr/>
-          <p:nvPr/>
-        </p:nvSpPr>
-        <p:spPr>
-          <a:xfrm>
-            <a:off x="731520" y="1188720"/>
-            <a:ext cx="7680960" cy="2743200"/>
-          </a:xfrm>
-          <a:prstGeom prst="rect">
-            <a:avLst/>
-          </a:prstGeom>
-          <a:noFill/>
-          <a:ln/>
-        </p:spPr>
-        <p:txBody>
-          <a:bodyPr wrap="square" rtlCol="0" anchor="t"/>
-          <a:lstStyle/>
-          <a:p>
-            <a:pPr marL="152400" indent="-152400">
-              <a:spcAft>
-                <a:spcPts val="800"/>
-              </a:spcAft>
-              <a:buSzPct val="100000"/>
-              <a:buChar char="•"/>
-            </a:pPr>
-            <a:r>
-              <a:rPr lang="en-US" sz="1500" dirty="0">
-                <a:solidFill>
-                  <a:srgbClr val="1C1917"/>
-                </a:solidFill>
-                <a:latin typeface="Arial" pitchFamily="34" charset="0"/>
-                <a:ea typeface="Arial" pitchFamily="34" charset="-122"/>
-                <a:cs typeface="Arial" pitchFamily="34" charset="-120"/>
-              </a:rPr>
-              <a:t>Compare implied exit multiple to industry EV/EBITDA benchmarks.</a:t>
-            </a:r>
-            <a:endParaRPr lang="en-US" sz="1500" dirty="0"/>
-          </a:p>
-          <a:p>
-            <a:pPr marL="152400" indent="-152400">
-              <a:spcAft>
-                <a:spcPts val="800"/>
-              </a:spcAft>
-              <a:buSzPct val="100000"/>
-              <a:buChar char="•"/>
-            </a:pPr>
-            <a:r>
-              <a:rPr lang="en-US" sz="1500" dirty="0">
-                <a:solidFill>
-                  <a:srgbClr val="1C1917"/>
-                </a:solidFill>
-                <a:latin typeface="Arial" pitchFamily="34" charset="0"/>
-                <a:ea typeface="Arial" pitchFamily="34" charset="-122"/>
-                <a:cs typeface="Arial" pitchFamily="34" charset="-120"/>
-              </a:rPr>
-              <a:t>Run sensitivity: WACC ±1% and terminal growth ±0.5%.</a:t>
-            </a:r>
-            <a:endParaRPr lang="en-US" sz="1500" dirty="0"/>
-          </a:p>
-          <a:p>
-            <a:pPr marL="152400" indent="-152400">
-              <a:spcAft>
-                <a:spcPts val="800"/>
-              </a:spcAft>
-              <a:buSzPct val="100000"/>
-              <a:buChar char="•"/>
-            </a:pPr>
-            <a:r>
-              <a:rPr lang="en-US" sz="1500" dirty="0">
-                <a:solidFill>
-                  <a:srgbClr val="1C1917"/>
-                </a:solidFill>
-                <a:latin typeface="Arial" pitchFamily="34" charset="0"/>
-                <a:ea typeface="Arial" pitchFamily="34" charset="-122"/>
-                <a:cs typeface="Arial" pitchFamily="34" charset="-120"/>
-              </a:rPr>
-              <a:t>Cross-check intrinsic value against trading comparable multiples.</a:t>
-            </a:r>
-            <a:endParaRPr lang="en-US" sz="1500" dirty="0"/>
-          </a:p>
-          <a:p>
-            <a:pPr marL="152400" indent="-152400">
-              <a:spcAft>
-                <a:spcPts val="800"/>
-              </a:spcAft>
-              <a:buSzPct val="100000"/>
-              <a:buChar char="•"/>
-            </a:pPr>
-            <a:r>
-              <a:rPr lang="en-US" sz="1500" dirty="0">
-                <a:solidFill>
-                  <a:srgbClr val="1C1917"/>
-                </a:solidFill>
-                <a:latin typeface="Arial" pitchFamily="34" charset="0"/>
-                <a:ea typeface="Arial" pitchFamily="34" charset="-122"/>
-                <a:cs typeface="Arial" pitchFamily="34" charset="-120"/>
-              </a:rPr>
-              <a:t>Confirm nominal and real inputs are used consistently throughout.</a:t>
-            </a:r>
-            <a:endParaRPr lang="en-US" sz="1500" dirty="0"/>
-          </a:p>
-          <a:p>
-            <a:pPr marL="152400" indent="-152400">
-              <a:spcAft>
-                <a:spcPts val="800"/>
-              </a:spcAft>
-              <a:buSzPct val="100000"/>
-              <a:buChar char="•"/>
-            </a:pPr>
-            <a:r>
-              <a:rPr lang="en-US" sz="1500" dirty="0">
-                <a:solidFill>
-                  <a:srgbClr val="1C1917"/>
-                </a:solidFill>
-                <a:latin typeface="Arial" pitchFamily="34" charset="0"/>
-                <a:ea typeface="Arial" pitchFamily="34" charset="-122"/>
-                <a:cs typeface="Arial" pitchFamily="34" charset="-120"/>
-              </a:rPr>
-              <a:t>Reconcile net income to FCF line by line before finalizing.</a:t>
-            </a:r>
-            <a:endParaRPr lang="en-US" sz="1500" dirty="0"/>
-          </a:p>
-        </p:txBody>
-      </p:sp>
-      <p:sp>
-        <p:nvSpPr>
-          <p:cNvPr id="7" name="Shape 5"/>
-          <p:cNvSpPr/>
-          <p:nvPr/>
-        </p:nvSpPr>
-        <p:spPr>
-          <a:xfrm>
-            <a:off x="731520" y="4041648"/>
-            <a:ext cx="7680960" cy="566928"/>
-          </a:xfrm>
-          <a:prstGeom prst="roundRect">
-            <a:avLst>
-              <a:gd name="adj" fmla="val 12903"/>
-            </a:avLst>
+          <p:cNvPr id="6" name="Shape 4"/>
+          <p:cNvSpPr/>
+          <p:nvPr/>
+        </p:nvSpPr>
+        <p:spPr>
+          <a:xfrm flipV="1">
+            <a:off x="1988820" y="1234440"/>
+            <a:ext cx="2240280" cy="713232"/>
+          </a:xfrm>
+          <a:prstGeom prst="trapezoid">
+            <a:avLst/>
           </a:prstGeom>
           <a:solidFill>
             <a:srgbClr val="B45309">
-              <a:alpha val="12000"/>
+              <a:alpha val="40000"/>
             </a:srgbClr>
           </a:solidFill>
-          <a:ln w="12700">
-            <a:solidFill>
-              <a:srgbClr val="B45309"/>
-            </a:solidFill>
-            <a:prstDash val="solid"/>
-          </a:ln>
-        </p:spPr>
+          <a:ln/>
+        </p:spPr>
+      </p:sp>
+      <p:sp>
+        <p:nvSpPr>
+          <p:cNvPr id="7" name="Text 5"/>
+          <p:cNvSpPr/>
+          <p:nvPr/>
+        </p:nvSpPr>
+        <p:spPr>
+          <a:xfrm>
+            <a:off x="1988820" y="1289304"/>
+            <a:ext cx="2240280" cy="621792"/>
+          </a:xfrm>
+          <a:prstGeom prst="rect">
+            <a:avLst/>
+          </a:prstGeom>
+          <a:noFill/>
+          <a:ln/>
+        </p:spPr>
+        <p:txBody>
+          <a:bodyPr wrap="square" rtlCol="0" anchor="ctr"/>
+          <a:lstStyle/>
+          <a:p>
+            <a:pPr algn="ctr" indent="0" marL="0">
+              <a:buNone/>
+            </a:pPr>
+            <a:r>
+              <a:rPr lang="en-US" sz="1200" b="1" dirty="0">
+                <a:solidFill>
+                  <a:srgbClr val="FFFFFF"/>
+                </a:solidFill>
+                <a:latin typeface="Arial" pitchFamily="34" charset="0"/>
+                <a:ea typeface="Arial" pitchFamily="34" charset="-122"/>
+                <a:cs typeface="Arial" pitchFamily="34" charset="-120"/>
+              </a:rPr>
+              <a:t>FCFF (Output)</a:t>
+            </a:r>
+            <a:endParaRPr lang="en-US" sz="1200" dirty="0"/>
+          </a:p>
+        </p:txBody>
       </p:sp>
       <p:sp>
         <p:nvSpPr>
@@ -2319,8 +2329,8 @@
         </p:nvSpPr>
         <p:spPr>
           <a:xfrm>
-            <a:off x="868680" y="4087368"/>
-            <a:ext cx="7406640" cy="475488"/>
+            <a:off x="5760720" y="1444752"/>
+            <a:ext cx="2926080" cy="310896"/>
           </a:xfrm>
           <a:prstGeom prst="rect">
             <a:avLst/>
@@ -2336,31 +2346,317 @@
               <a:buNone/>
             </a:pPr>
             <a:r>
-              <a:rPr lang="en-US" sz="1100" b="1" dirty="0">
-                <a:solidFill>
-                  <a:srgbClr val="B45309"/>
-                </a:solidFill>
-                <a:latin typeface="Arial" pitchFamily="34" charset="0"/>
-                <a:ea typeface="Arial" pitchFamily="34" charset="-122"/>
-                <a:cs typeface="Arial" pitchFamily="34" charset="-120"/>
-              </a:rPr>
-              <a:t>Takeaway  </a:t>
-            </a:r>
+              <a:rPr lang="en-US" sz="1000" dirty="0">
+                <a:solidFill>
+                  <a:srgbClr val="78716C"/>
+                </a:solidFill>
+                <a:latin typeface="Arial" pitchFamily="34" charset="0"/>
+                <a:ea typeface="Arial" pitchFamily="34" charset="-122"/>
+                <a:cs typeface="Arial" pitchFamily="34" charset="-120"/>
+              </a:rPr>
+              <a:t>Cash available to all capital providers</a:t>
+            </a:r>
+            <a:endParaRPr lang="en-US" sz="1000" dirty="0"/>
+          </a:p>
+        </p:txBody>
+      </p:sp>
+      <p:sp>
+        <p:nvSpPr>
+          <p:cNvPr id="9" name="Shape 7"/>
+          <p:cNvSpPr/>
+          <p:nvPr/>
+        </p:nvSpPr>
+        <p:spPr>
+          <a:xfrm flipV="1">
+            <a:off x="1508760" y="2039112"/>
+            <a:ext cx="3200400" cy="713232"/>
+          </a:xfrm>
+          <a:prstGeom prst="trapezoid">
+            <a:avLst/>
+          </a:prstGeom>
+          <a:solidFill>
+            <a:srgbClr val="B45309">
+              <a:alpha val="58000"/>
+            </a:srgbClr>
+          </a:solidFill>
+          <a:ln/>
+        </p:spPr>
+      </p:sp>
+      <p:sp>
+        <p:nvSpPr>
+          <p:cNvPr id="10" name="Text 8"/>
+          <p:cNvSpPr/>
+          <p:nvPr/>
+        </p:nvSpPr>
+        <p:spPr>
+          <a:xfrm>
+            <a:off x="1508760" y="2093976"/>
+            <a:ext cx="3200400" cy="621792"/>
+          </a:xfrm>
+          <a:prstGeom prst="rect">
+            <a:avLst/>
+          </a:prstGeom>
+          <a:noFill/>
+          <a:ln/>
+        </p:spPr>
+        <p:txBody>
+          <a:bodyPr wrap="square" rtlCol="0" anchor="ctr"/>
+          <a:lstStyle/>
+          <a:p>
+            <a:pPr algn="ctr" indent="0" marL="0">
+              <a:buNone/>
+            </a:pPr>
+            <a:r>
+              <a:rPr lang="en-US" sz="1200" b="1" dirty="0">
+                <a:solidFill>
+                  <a:srgbClr val="FFFFFF"/>
+                </a:solidFill>
+                <a:latin typeface="Arial" pitchFamily="34" charset="0"/>
+                <a:ea typeface="Arial" pitchFamily="34" charset="-122"/>
+                <a:cs typeface="Arial" pitchFamily="34" charset="-120"/>
+              </a:rPr>
+              <a:t>NOPAT (EBIT×(1−Tax))</a:t>
+            </a:r>
+            <a:endParaRPr lang="en-US" sz="1200" dirty="0"/>
+          </a:p>
+        </p:txBody>
+      </p:sp>
+      <p:sp>
+        <p:nvSpPr>
+          <p:cNvPr id="11" name="Text 9"/>
+          <p:cNvSpPr/>
+          <p:nvPr/>
+        </p:nvSpPr>
+        <p:spPr>
+          <a:xfrm>
+            <a:off x="5760720" y="2249424"/>
+            <a:ext cx="2926080" cy="310896"/>
+          </a:xfrm>
+          <a:prstGeom prst="rect">
+            <a:avLst/>
+          </a:prstGeom>
+          <a:noFill/>
+          <a:ln/>
+        </p:spPr>
+        <p:txBody>
+          <a:bodyPr wrap="square" rtlCol="0" anchor="ctr"/>
+          <a:lstStyle/>
+          <a:p>
             <a:pPr indent="0" marL="0">
               <a:buNone/>
             </a:pPr>
             <a:r>
-              <a:rPr lang="en-US" sz="1150" dirty="0">
-                <a:solidFill>
-                  <a:srgbClr val="1C1917"/>
-                </a:solidFill>
-                <a:latin typeface="Arial" pitchFamily="34" charset="0"/>
-                <a:ea typeface="Arial" pitchFamily="34" charset="-122"/>
-                <a:cs typeface="Arial" pitchFamily="34" charset="-120"/>
-              </a:rPr>
-              <a:t>Disciplined sanity checks transform a mechanical DCF exercise into a credible, defensible valuation.</a:t>
-            </a:r>
-            <a:endParaRPr lang="en-US" sz="1100" dirty="0"/>
+              <a:rPr lang="en-US" sz="1000" dirty="0">
+                <a:solidFill>
+                  <a:srgbClr val="78716C"/>
+                </a:solidFill>
+                <a:latin typeface="Arial" pitchFamily="34" charset="0"/>
+                <a:ea typeface="Arial" pitchFamily="34" charset="-122"/>
+                <a:cs typeface="Arial" pitchFamily="34" charset="-120"/>
+              </a:rPr>
+              <a:t>Operating profit stripped of financing effects</a:t>
+            </a:r>
+            <a:endParaRPr lang="en-US" sz="1000" dirty="0"/>
+          </a:p>
+        </p:txBody>
+      </p:sp>
+      <p:sp>
+        <p:nvSpPr>
+          <p:cNvPr id="12" name="Shape 10"/>
+          <p:cNvSpPr/>
+          <p:nvPr/>
+        </p:nvSpPr>
+        <p:spPr>
+          <a:xfrm flipV="1">
+            <a:off x="1028700" y="2843784"/>
+            <a:ext cx="4160520" cy="713232"/>
+          </a:xfrm>
+          <a:prstGeom prst="trapezoid">
+            <a:avLst/>
+          </a:prstGeom>
+          <a:solidFill>
+            <a:srgbClr val="B45309">
+              <a:alpha val="77000"/>
+            </a:srgbClr>
+          </a:solidFill>
+          <a:ln/>
+        </p:spPr>
+      </p:sp>
+      <p:sp>
+        <p:nvSpPr>
+          <p:cNvPr id="13" name="Text 11"/>
+          <p:cNvSpPr/>
+          <p:nvPr/>
+        </p:nvSpPr>
+        <p:spPr>
+          <a:xfrm>
+            <a:off x="1028700" y="2898648"/>
+            <a:ext cx="4160520" cy="621792"/>
+          </a:xfrm>
+          <a:prstGeom prst="rect">
+            <a:avLst/>
+          </a:prstGeom>
+          <a:noFill/>
+          <a:ln/>
+        </p:spPr>
+        <p:txBody>
+          <a:bodyPr wrap="square" rtlCol="0" anchor="ctr"/>
+          <a:lstStyle/>
+          <a:p>
+            <a:pPr algn="ctr" indent="0" marL="0">
+              <a:buNone/>
+            </a:pPr>
+            <a:r>
+              <a:rPr lang="en-US" sz="1200" b="1" dirty="0">
+                <a:solidFill>
+                  <a:srgbClr val="FFFFFF"/>
+                </a:solidFill>
+                <a:latin typeface="Arial" pitchFamily="34" charset="0"/>
+                <a:ea typeface="Arial" pitchFamily="34" charset="-122"/>
+                <a:cs typeface="Arial" pitchFamily="34" charset="-120"/>
+              </a:rPr>
+              <a:t>Add Back D&amp;A</a:t>
+            </a:r>
+            <a:endParaRPr lang="en-US" sz="1200" dirty="0"/>
+          </a:p>
+        </p:txBody>
+      </p:sp>
+      <p:sp>
+        <p:nvSpPr>
+          <p:cNvPr id="14" name="Text 12"/>
+          <p:cNvSpPr/>
+          <p:nvPr/>
+        </p:nvSpPr>
+        <p:spPr>
+          <a:xfrm>
+            <a:off x="5760720" y="3054096"/>
+            <a:ext cx="2926080" cy="310896"/>
+          </a:xfrm>
+          <a:prstGeom prst="rect">
+            <a:avLst/>
+          </a:prstGeom>
+          <a:noFill/>
+          <a:ln/>
+        </p:spPr>
+        <p:txBody>
+          <a:bodyPr wrap="square" rtlCol="0" anchor="ctr"/>
+          <a:lstStyle/>
+          <a:p>
+            <a:pPr indent="0" marL="0">
+              <a:buNone/>
+            </a:pPr>
+            <a:r>
+              <a:rPr lang="en-US" sz="1000" dirty="0">
+                <a:solidFill>
+                  <a:srgbClr val="78716C"/>
+                </a:solidFill>
+                <a:latin typeface="Arial" pitchFamily="34" charset="0"/>
+                <a:ea typeface="Arial" pitchFamily="34" charset="-122"/>
+                <a:cs typeface="Arial" pitchFamily="34" charset="-120"/>
+              </a:rPr>
+              <a:t>Non-cash charge; restores operating cash</a:t>
+            </a:r>
+            <a:endParaRPr lang="en-US" sz="1000" dirty="0"/>
+          </a:p>
+        </p:txBody>
+      </p:sp>
+      <p:sp>
+        <p:nvSpPr>
+          <p:cNvPr id="15" name="Shape 13"/>
+          <p:cNvSpPr/>
+          <p:nvPr/>
+        </p:nvSpPr>
+        <p:spPr>
+          <a:xfrm flipV="1">
+            <a:off x="548640" y="3648456"/>
+            <a:ext cx="5120640" cy="713232"/>
+          </a:xfrm>
+          <a:prstGeom prst="trapezoid">
+            <a:avLst/>
+          </a:prstGeom>
+          <a:solidFill>
+            <a:srgbClr val="B45309">
+              <a:alpha val="95000"/>
+            </a:srgbClr>
+          </a:solidFill>
+          <a:ln/>
+        </p:spPr>
+      </p:sp>
+      <p:sp>
+        <p:nvSpPr>
+          <p:cNvPr id="16" name="Text 14"/>
+          <p:cNvSpPr/>
+          <p:nvPr/>
+        </p:nvSpPr>
+        <p:spPr>
+          <a:xfrm>
+            <a:off x="548640" y="3703320"/>
+            <a:ext cx="5120640" cy="621792"/>
+          </a:xfrm>
+          <a:prstGeom prst="rect">
+            <a:avLst/>
+          </a:prstGeom>
+          <a:noFill/>
+          <a:ln/>
+        </p:spPr>
+        <p:txBody>
+          <a:bodyPr wrap="square" rtlCol="0" anchor="ctr"/>
+          <a:lstStyle/>
+          <a:p>
+            <a:pPr algn="ctr" indent="0" marL="0">
+              <a:buNone/>
+            </a:pPr>
+            <a:r>
+              <a:rPr lang="en-US" sz="1200" b="1" dirty="0">
+                <a:solidFill>
+                  <a:srgbClr val="FFFFFF"/>
+                </a:solidFill>
+                <a:latin typeface="Arial" pitchFamily="34" charset="0"/>
+                <a:ea typeface="Arial" pitchFamily="34" charset="-122"/>
+                <a:cs typeface="Arial" pitchFamily="34" charset="-120"/>
+              </a:rPr>
+              <a:t>Subtract CapEx &amp; ΔNWC</a:t>
+            </a:r>
+            <a:endParaRPr lang="en-US" sz="1200" dirty="0"/>
+          </a:p>
+        </p:txBody>
+      </p:sp>
+      <p:sp>
+        <p:nvSpPr>
+          <p:cNvPr id="17" name="Text 15"/>
+          <p:cNvSpPr/>
+          <p:nvPr/>
+        </p:nvSpPr>
+        <p:spPr>
+          <a:xfrm>
+            <a:off x="5760720" y="3858768"/>
+            <a:ext cx="2926080" cy="310896"/>
+          </a:xfrm>
+          <a:prstGeom prst="rect">
+            <a:avLst/>
+          </a:prstGeom>
+          <a:noFill/>
+          <a:ln/>
+        </p:spPr>
+        <p:txBody>
+          <a:bodyPr wrap="square" rtlCol="0" anchor="ctr"/>
+          <a:lstStyle/>
+          <a:p>
+            <a:pPr indent="0" marL="0">
+              <a:buNone/>
+            </a:pPr>
+            <a:r>
+              <a:rPr lang="en-US" sz="1000" dirty="0">
+                <a:solidFill>
+                  <a:srgbClr val="78716C"/>
+                </a:solidFill>
+                <a:latin typeface="Arial" pitchFamily="34" charset="0"/>
+                <a:ea typeface="Arial" pitchFamily="34" charset="-122"/>
+                <a:cs typeface="Arial" pitchFamily="34" charset="-120"/>
+              </a:rPr>
+              <a:t>Reinvestment needed to sustain growth</a:t>
+            </a:r>
+            <a:endParaRPr lang="en-US" sz="1000" dirty="0"/>
           </a:p>
         </p:txBody>
       </p:sp>
@@ -2404,6 +2700,368 @@
         </p:nvSpPr>
         <p:spPr>
           <a:xfrm>
+            <a:off x="411480" y="402336"/>
+            <a:ext cx="82296" cy="329184"/>
+          </a:xfrm>
+          <a:prstGeom prst="rect">
+            <a:avLst/>
+          </a:prstGeom>
+          <a:solidFill>
+            <a:srgbClr val="B45309"/>
+          </a:solidFill>
+          <a:ln/>
+        </p:spPr>
+      </p:sp>
+      <p:sp>
+        <p:nvSpPr>
+          <p:cNvPr id="3" name="Text 1"/>
+          <p:cNvSpPr/>
+          <p:nvPr/>
+        </p:nvSpPr>
+        <p:spPr>
+          <a:xfrm>
+            <a:off x="566928" y="292608"/>
+            <a:ext cx="8138160" cy="548640"/>
+          </a:xfrm>
+          <a:prstGeom prst="rect">
+            <a:avLst/>
+          </a:prstGeom>
+          <a:noFill/>
+          <a:ln/>
+        </p:spPr>
+        <p:txBody>
+          <a:bodyPr wrap="square" rtlCol="0" anchor="ctr"/>
+          <a:lstStyle/>
+          <a:p>
+            <a:pPr indent="0" marL="0">
+              <a:buNone/>
+            </a:pPr>
+            <a:r>
+              <a:rPr lang="en-US" sz="2100" b="1" dirty="0">
+                <a:solidFill>
+                  <a:srgbClr val="1C1917"/>
+                </a:solidFill>
+                <a:latin typeface="Arial" pitchFamily="34" charset="0"/>
+                <a:ea typeface="Arial" pitchFamily="34" charset="-122"/>
+                <a:cs typeface="Arial" pitchFamily="34" charset="-120"/>
+              </a:rPr>
+              <a:t>Sensitivity Analysis and Critical Evaluation of DCF Outputs</a:t>
+            </a:r>
+            <a:endParaRPr lang="en-US" sz="2100" dirty="0"/>
+          </a:p>
+        </p:txBody>
+      </p:sp>
+      <p:sp>
+        <p:nvSpPr>
+          <p:cNvPr id="4" name="Shape 2"/>
+          <p:cNvSpPr/>
+          <p:nvPr/>
+        </p:nvSpPr>
+        <p:spPr>
+          <a:xfrm>
+            <a:off x="411480" y="960120"/>
+            <a:ext cx="8321040" cy="0"/>
+          </a:xfrm>
+          <a:prstGeom prst="line">
+            <a:avLst/>
+          </a:prstGeom>
+          <a:noFill/>
+          <a:ln w="12700">
+            <a:solidFill>
+              <a:srgbClr val="E7E5E4"/>
+            </a:solidFill>
+            <a:prstDash val="solid"/>
+          </a:ln>
+        </p:spPr>
+      </p:sp>
+      <p:sp>
+        <p:nvSpPr>
+          <p:cNvPr id="5" name="Text 3"/>
+          <p:cNvSpPr/>
+          <p:nvPr/>
+        </p:nvSpPr>
+        <p:spPr>
+          <a:xfrm>
+            <a:off x="411480" y="4864608"/>
+            <a:ext cx="8321040" cy="237744"/>
+          </a:xfrm>
+          <a:prstGeom prst="rect">
+            <a:avLst/>
+          </a:prstGeom>
+          <a:noFill/>
+          <a:ln/>
+        </p:spPr>
+        <p:txBody>
+          <a:bodyPr wrap="square" rtlCol="0" anchor="ctr"/>
+          <a:lstStyle/>
+          <a:p>
+            <a:pPr indent="0" marL="0">
+              <a:buNone/>
+            </a:pPr>
+            <a:r>
+              <a:rPr lang="en-US" sz="750" dirty="0">
+                <a:solidFill>
+                  <a:srgbClr val="AAAAAA"/>
+                </a:solidFill>
+                <a:latin typeface="Arial" pitchFamily="34" charset="0"/>
+                <a:ea typeface="Arial" pitchFamily="34" charset="-122"/>
+                <a:cs typeface="Arial" pitchFamily="34" charset="-120"/>
+              </a:rPr>
+              <a:t>Lesson Forge Pro (owner) — This content is educational material only and does not constitute financial, investment, or trading advice.</a:t>
+            </a:r>
+            <a:endParaRPr lang="en-US" sz="750" dirty="0"/>
+          </a:p>
+        </p:txBody>
+      </p:sp>
+      <p:sp>
+        <p:nvSpPr>
+          <p:cNvPr id="6" name="Text 4"/>
+          <p:cNvSpPr/>
+          <p:nvPr/>
+        </p:nvSpPr>
+        <p:spPr>
+          <a:xfrm>
+            <a:off x="731520" y="1188720"/>
+            <a:ext cx="7680960" cy="2743200"/>
+          </a:xfrm>
+          <a:prstGeom prst="rect">
+            <a:avLst/>
+          </a:prstGeom>
+          <a:noFill/>
+          <a:ln/>
+        </p:spPr>
+        <p:txBody>
+          <a:bodyPr wrap="square" rtlCol="0" anchor="t"/>
+          <a:lstStyle/>
+          <a:p>
+            <a:pPr marL="152400" indent="-152400">
+              <a:spcAft>
+                <a:spcPts val="800"/>
+              </a:spcAft>
+              <a:buSzPct val="100000"/>
+              <a:buChar char="•"/>
+            </a:pPr>
+            <a:r>
+              <a:rPr lang="en-US" sz="1500" dirty="0">
+                <a:solidFill>
+                  <a:srgbClr val="1C1917"/>
+                </a:solidFill>
+                <a:latin typeface="Arial" pitchFamily="34" charset="0"/>
+                <a:ea typeface="Arial" pitchFamily="34" charset="-122"/>
+                <a:cs typeface="Arial" pitchFamily="34" charset="-120"/>
+              </a:rPr>
+              <a:t>A single DCF output is fragile; always present a range of values.</a:t>
+            </a:r>
+            <a:endParaRPr lang="en-US" sz="1500" dirty="0"/>
+          </a:p>
+          <a:p>
+            <a:pPr marL="152400" indent="-152400">
+              <a:spcAft>
+                <a:spcPts val="800"/>
+              </a:spcAft>
+              <a:buSzPct val="100000"/>
+              <a:buChar char="•"/>
+            </a:pPr>
+            <a:r>
+              <a:rPr lang="en-US" sz="1500" dirty="0">
+                <a:solidFill>
+                  <a:srgbClr val="1C1917"/>
+                </a:solidFill>
+                <a:latin typeface="Arial" pitchFamily="34" charset="0"/>
+                <a:ea typeface="Arial" pitchFamily="34" charset="-122"/>
+                <a:cs typeface="Arial" pitchFamily="34" charset="-120"/>
+              </a:rPr>
+              <a:t>WACC and terminal growth rate are the two highest-impact variables.</a:t>
+            </a:r>
+            <a:endParaRPr lang="en-US" sz="1500" dirty="0"/>
+          </a:p>
+          <a:p>
+            <a:pPr marL="152400" indent="-152400">
+              <a:spcAft>
+                <a:spcPts val="800"/>
+              </a:spcAft>
+              <a:buSzPct val="100000"/>
+              <a:buChar char="•"/>
+            </a:pPr>
+            <a:r>
+              <a:rPr lang="en-US" sz="1500" dirty="0">
+                <a:solidFill>
+                  <a:srgbClr val="1C1917"/>
+                </a:solidFill>
+                <a:latin typeface="Arial" pitchFamily="34" charset="0"/>
+                <a:ea typeface="Arial" pitchFamily="34" charset="-122"/>
+                <a:cs typeface="Arial" pitchFamily="34" charset="-120"/>
+              </a:rPr>
+              <a:t>Two-variable data tables reveal how quickly value swings with small changes.</a:t>
+            </a:r>
+            <a:endParaRPr lang="en-US" sz="1500" dirty="0"/>
+          </a:p>
+          <a:p>
+            <a:pPr marL="152400" indent="-152400">
+              <a:spcAft>
+                <a:spcPts val="800"/>
+              </a:spcAft>
+              <a:buSzPct val="100000"/>
+              <a:buChar char="•"/>
+            </a:pPr>
+            <a:r>
+              <a:rPr lang="en-US" sz="1500" dirty="0">
+                <a:solidFill>
+                  <a:srgbClr val="1C1917"/>
+                </a:solidFill>
+                <a:latin typeface="Arial" pitchFamily="34" charset="0"/>
+                <a:ea typeface="Arial" pitchFamily="34" charset="-122"/>
+                <a:cs typeface="Arial" pitchFamily="34" charset="-120"/>
+              </a:rPr>
+              <a:t>Compounding assumption errors can move equity value by hundreds of millions.</a:t>
+            </a:r>
+            <a:endParaRPr lang="en-US" sz="1500" dirty="0"/>
+          </a:p>
+          <a:p>
+            <a:pPr marL="152400" indent="-152400">
+              <a:spcAft>
+                <a:spcPts val="800"/>
+              </a:spcAft>
+              <a:buSzPct val="100000"/>
+              <a:buChar char="•"/>
+            </a:pPr>
+            <a:r>
+              <a:rPr lang="en-US" sz="1500" dirty="0">
+                <a:solidFill>
+                  <a:srgbClr val="1C1917"/>
+                </a:solidFill>
+                <a:latin typeface="Arial" pitchFamily="34" charset="0"/>
+                <a:ea typeface="Arial" pitchFamily="34" charset="-122"/>
+                <a:cs typeface="Arial" pitchFamily="34" charset="-120"/>
+              </a:rPr>
+              <a:t>Sensitivity analysis distinguishes rigorous analysts from overconfident ones.</a:t>
+            </a:r>
+            <a:endParaRPr lang="en-US" sz="1500" dirty="0"/>
+          </a:p>
+        </p:txBody>
+      </p:sp>
+      <p:sp>
+        <p:nvSpPr>
+          <p:cNvPr id="7" name="Shape 5"/>
+          <p:cNvSpPr/>
+          <p:nvPr/>
+        </p:nvSpPr>
+        <p:spPr>
+          <a:xfrm>
+            <a:off x="731520" y="4041648"/>
+            <a:ext cx="7680960" cy="566928"/>
+          </a:xfrm>
+          <a:prstGeom prst="roundRect">
+            <a:avLst>
+              <a:gd name="adj" fmla="val 12903"/>
+            </a:avLst>
+          </a:prstGeom>
+          <a:solidFill>
+            <a:srgbClr val="B45309">
+              <a:alpha val="12000"/>
+            </a:srgbClr>
+          </a:solidFill>
+          <a:ln w="12700">
+            <a:solidFill>
+              <a:srgbClr val="B45309"/>
+            </a:solidFill>
+            <a:prstDash val="solid"/>
+          </a:ln>
+        </p:spPr>
+      </p:sp>
+      <p:sp>
+        <p:nvSpPr>
+          <p:cNvPr id="8" name="Text 6"/>
+          <p:cNvSpPr/>
+          <p:nvPr/>
+        </p:nvSpPr>
+        <p:spPr>
+          <a:xfrm>
+            <a:off x="868680" y="4087368"/>
+            <a:ext cx="7406640" cy="475488"/>
+          </a:xfrm>
+          <a:prstGeom prst="rect">
+            <a:avLst/>
+          </a:prstGeom>
+          <a:noFill/>
+          <a:ln/>
+        </p:spPr>
+        <p:txBody>
+          <a:bodyPr wrap="square" rtlCol="0" anchor="ctr"/>
+          <a:lstStyle/>
+          <a:p>
+            <a:pPr indent="0" marL="0">
+              <a:buNone/>
+            </a:pPr>
+            <a:r>
+              <a:rPr lang="en-US" sz="1100" b="1" dirty="0">
+                <a:solidFill>
+                  <a:srgbClr val="B45309"/>
+                </a:solidFill>
+                <a:latin typeface="Arial" pitchFamily="34" charset="0"/>
+                <a:ea typeface="Arial" pitchFamily="34" charset="-122"/>
+                <a:cs typeface="Arial" pitchFamily="34" charset="-120"/>
+              </a:rPr>
+              <a:t>Takeaway  </a:t>
+            </a:r>
+            <a:pPr indent="0" marL="0">
+              <a:buNone/>
+            </a:pPr>
+            <a:r>
+              <a:rPr lang="en-US" sz="1150" dirty="0">
+                <a:solidFill>
+                  <a:srgbClr val="1C1917"/>
+                </a:solidFill>
+                <a:latin typeface="Arial" pitchFamily="34" charset="0"/>
+                <a:ea typeface="Arial" pitchFamily="34" charset="-122"/>
+                <a:cs typeface="Arial" pitchFamily="34" charset="-120"/>
+              </a:rPr>
+              <a:t>Sensitivity analysis converts a point estimate into a defensible value range, exposing which assumptions truly drive your conclusion.</a:t>
+            </a:r>
+            <a:endParaRPr lang="en-US" sz="1100" dirty="0"/>
+          </a:p>
+        </p:txBody>
+      </p:sp>
+    </p:spTree>
+  </p:cSld>
+  <p:clrMapOvr>
+    <a:masterClrMapping/>
+  </p:clrMapOvr>
+</p:sld>
+</file>
+
+<file path=ppt/slides/slide12.xml><?xml version="1.0" encoding="utf-8"?>
+<p:sld xmlns:a="http://schemas.openxmlformats.org/drawingml/2006/main" xmlns:r="http://schemas.openxmlformats.org/officeDocument/2006/relationships" xmlns:p="http://schemas.openxmlformats.org/presentationml/2006/main">
+  <p:cSld name="Slide 12">
+    <p:bg>
+      <p:bgPr>
+        <a:solidFill>
+          <a:srgbClr val="FFFFFF"/>
+        </a:solidFill>
+      </p:bgPr>
+    </p:bg>
+    <p:spTree>
+      <p:nvGrpSpPr>
+        <p:cNvPr id="1" name=""/>
+        <p:cNvGrpSpPr/>
+        <p:nvPr/>
+      </p:nvGrpSpPr>
+      <p:grpSpPr>
+        <a:xfrm>
+          <a:off x="0" y="0"/>
+          <a:ext cx="0" cy="0"/>
+          <a:chOff x="0" y="0"/>
+          <a:chExt cx="0" cy="0"/>
+        </a:xfrm>
+      </p:grpSpPr>
+      <p:sp>
+        <p:nvSpPr>
+          <p:cNvPr id="2" name="Shape 0"/>
+          <p:cNvSpPr/>
+          <p:nvPr/>
+        </p:nvSpPr>
+        <p:spPr>
+          <a:xfrm>
             <a:off x="0" y="4480560"/>
             <a:ext cx="9144000" cy="667512"/>
           </a:xfrm>
@@ -2684,7 +3342,7 @@
                 <a:ea typeface="Arial" pitchFamily="34" charset="-122"/>
                 <a:cs typeface="Arial" pitchFamily="34" charset="-120"/>
               </a:rPr>
-              <a:t>DCF Concepts and Vocabulary</a:t>
+              <a:t>Time Value of Money and the DCF Discount Mechanism</a:t>
             </a:r>
             <a:endParaRPr lang="en-US" sz="1600" dirty="0"/>
           </a:p>
@@ -2705,7 +3363,7 @@
                 <a:ea typeface="Arial" pitchFamily="34" charset="-122"/>
                 <a:cs typeface="Arial" pitchFamily="34" charset="-120"/>
               </a:rPr>
-              <a:t>Standard DCF Procedure</a:t>
+              <a:t>Projecting Free Cash Flow to the Firm (FCFF)</a:t>
             </a:r>
             <a:endParaRPr lang="en-US" sz="1600" dirty="0"/>
           </a:p>
@@ -2726,7 +3384,7 @@
                 <a:ea typeface="Arial" pitchFamily="34" charset="-122"/>
                 <a:cs typeface="Arial" pitchFamily="34" charset="-120"/>
               </a:rPr>
-              <a:t>DCF Applications and Pitfalls</a:t>
+              <a:t>Calculating WACC as the DCF Discount Rate</a:t>
             </a:r>
             <a:endParaRPr lang="en-US" sz="1600" dirty="0"/>
           </a:p>
@@ -2747,7 +3405,7 @@
                 <a:ea typeface="Arial" pitchFamily="34" charset="-122"/>
                 <a:cs typeface="Arial" pitchFamily="34" charset="-120"/>
               </a:rPr>
-              <a:t>Worked Example: Correcting a Flawed DCF</a:t>
+              <a:t>Terminal Value: Gordon Growth Model and Exit Multiple Methods</a:t>
             </a:r>
             <a:endParaRPr lang="en-US" sz="1600" dirty="0"/>
           </a:p>
@@ -2768,7 +3426,28 @@
                 <a:ea typeface="Arial" pitchFamily="34" charset="-122"/>
                 <a:cs typeface="Arial" pitchFamily="34" charset="-120"/>
               </a:rPr>
-              <a:t>DCF Sanity Checks</a:t>
+              <a:t>Assembling the Full DCF Model and Deriving Equity Value</a:t>
+            </a:r>
+            <a:endParaRPr lang="en-US" sz="1600" dirty="0"/>
+          </a:p>
+          <a:p>
+            <a:pPr marL="177800" indent="-177800">
+              <a:spcAft>
+                <a:spcPts val="1000"/>
+              </a:spcAft>
+              <a:buSzPct val="100000"/>
+              <a:buChar char="▪"/>
+            </a:pPr>
+            <a:r>
+              <a:rPr lang="en-US" sz="1600" dirty="0">
+                <a:solidFill>
+                  <a:srgbClr val="1C1917"/>
+                </a:solidFill>
+                <a:latin typeface="Arial" pitchFamily="34" charset="0"/>
+                <a:ea typeface="Arial" pitchFamily="34" charset="-122"/>
+                <a:cs typeface="Arial" pitchFamily="34" charset="-120"/>
+              </a:rPr>
+              <a:t>Sensitivity Analysis and Critical Evaluation of DCF Outputs</a:t>
             </a:r>
             <a:endParaRPr lang="en-US" sz="1600" dirty="0"/>
           </a:p>
@@ -2859,7 +3538,7 @@
                 <a:ea typeface="Arial" pitchFamily="34" charset="-122"/>
                 <a:cs typeface="Arial" pitchFamily="34" charset="-120"/>
               </a:rPr>
-              <a:t>DCF Concepts and Vocabulary</a:t>
+              <a:t>Time Value of Money and the DCF Discount Mechanism</a:t>
             </a:r>
             <a:endParaRPr lang="en-US" sz="2100" dirty="0"/>
           </a:p>
@@ -2964,7 +3643,7 @@
                 <a:ea typeface="Arial" pitchFamily="34" charset="-122"/>
                 <a:cs typeface="Arial" pitchFamily="34" charset="-120"/>
               </a:rPr>
-              <a:t>Cash flow measures real money movement, not accounting profit.</a:t>
+              <a:t>A dollar today beats a future dollar due to opportunity cost and risk.</a:t>
             </a:r>
             <a:endParaRPr lang="en-US" sz="1500" dirty="0"/>
           </a:p>
@@ -2985,7 +3664,7 @@
                 <a:ea typeface="Arial" pitchFamily="34" charset="-122"/>
                 <a:cs typeface="Arial" pitchFamily="34" charset="-120"/>
               </a:rPr>
-              <a:t>Future Value (FV) is the nominal amount expected at a future date.</a:t>
+              <a:t>DCF converts future cash flows into comparable present-day equivalents.</a:t>
             </a:r>
             <a:endParaRPr lang="en-US" sz="1500" dirty="0"/>
           </a:p>
@@ -3006,7 +3685,7 @@
                 <a:ea typeface="Arial" pitchFamily="34" charset="-122"/>
                 <a:cs typeface="Arial" pitchFamily="34" charset="-120"/>
               </a:rPr>
-              <a:t>Present Value (PV) converts FV into today's equivalent worth.</a:t>
+              <a:t>Core formula: PV = FV / (1 + r)^n.</a:t>
             </a:r>
             <a:endParaRPr lang="en-US" sz="1500" dirty="0"/>
           </a:p>
@@ -3027,7 +3706,7 @@
                 <a:ea typeface="Arial" pitchFamily="34" charset="-122"/>
                 <a:cs typeface="Arial" pitchFamily="34" charset="-120"/>
               </a:rPr>
-              <a:t>Discount rate (r) reflects the risk and time cost of money.</a:t>
+              <a:t>Discount rate r reflects both required return and uncertainty.</a:t>
             </a:r>
             <a:endParaRPr lang="en-US" sz="1500" dirty="0"/>
           </a:p>
@@ -3048,7 +3727,7 @@
                 <a:ea typeface="Arial" pitchFamily="34" charset="-122"/>
                 <a:cs typeface="Arial" pitchFamily="34" charset="-120"/>
               </a:rPr>
-              <a:t>Discounting shrinks future cash flows back to present value.</a:t>
+              <a:t>Higher n or higher r shrinks present value dramatically.</a:t>
             </a:r>
             <a:endParaRPr lang="en-US" sz="1500" dirty="0"/>
           </a:p>
@@ -3130,7 +3809,7 @@
                 <a:ea typeface="Arial" pitchFamily="34" charset="-122"/>
                 <a:cs typeface="Arial" pitchFamily="34" charset="-120"/>
               </a:rPr>
-              <a:t>DCF valuation is built on four interlocking definitions: cash flow, future value, present value, and discount rate.</a:t>
+              <a:t>DCF valuation rests on one principle: future cash flows must be discounted to today's dollars before they can be meaningfully compared.</a:t>
             </a:r>
             <a:endParaRPr lang="en-US" sz="1100" dirty="0"/>
           </a:p>
@@ -3221,7 +3900,7 @@
                 <a:ea typeface="Arial" pitchFamily="34" charset="-122"/>
                 <a:cs typeface="Arial" pitchFamily="34" charset="-120"/>
               </a:rPr>
-              <a:t>Standard DCF Procedure</a:t>
+              <a:t>Projecting Free Cash Flow to the Firm (FCFF)</a:t>
             </a:r>
             <a:endParaRPr lang="en-US" sz="2100" dirty="0"/>
           </a:p>
@@ -3326,7 +4005,7 @@
                 <a:ea typeface="Arial" pitchFamily="34" charset="-122"/>
                 <a:cs typeface="Arial" pitchFamily="34" charset="-120"/>
               </a:rPr>
-              <a:t>Gather projected free cash flows over a 5–10 year horizon.</a:t>
+              <a:t>FCFF = EBIT × (1 − Tax Rate) + D&amp;A − CapEx − ΔNWC.</a:t>
             </a:r>
             <a:endParaRPr lang="en-US" sz="1500" dirty="0"/>
           </a:p>
@@ -3347,7 +4026,7 @@
                 <a:ea typeface="Arial" pitchFamily="34" charset="-122"/>
                 <a:cs typeface="Arial" pitchFamily="34" charset="-120"/>
               </a:rPr>
-              <a:t>Select a discount rate (typically WACC) matching cash flow risk.</a:t>
+              <a:t>Starting from EBIT removes financing costs, making FCFF capital-structure-neutral.</a:t>
             </a:r>
             <a:endParaRPr lang="en-US" sz="1500" dirty="0"/>
           </a:p>
@@ -3368,7 +4047,7 @@
                 <a:ea typeface="Arial" pitchFamily="34" charset="-122"/>
                 <a:cs typeface="Arial" pitchFamily="34" charset="-120"/>
               </a:rPr>
-              <a:t>Estimate terminal value via perpetuity growth or exit multiple.</a:t>
+              <a:t>Revenue growth is the single driver that flows through every line item.</a:t>
             </a:r>
             <a:endParaRPr lang="en-US" sz="1500" dirty="0"/>
           </a:p>
@@ -3389,7 +4068,7 @@
                 <a:ea typeface="Arial" pitchFamily="34" charset="-122"/>
                 <a:cs typeface="Arial" pitchFamily="34" charset="-120"/>
               </a:rPr>
-              <a:t>Discount all cash flows and terminal value to today.</a:t>
+              <a:t>FCFF represents cash available to both equity and debt holders.</a:t>
             </a:r>
             <a:endParaRPr lang="en-US" sz="1500" dirty="0"/>
           </a:p>
@@ -3410,7 +4089,7 @@
                 <a:ea typeface="Arial" pitchFamily="34" charset="-122"/>
                 <a:cs typeface="Arial" pitchFamily="34" charset="-120"/>
               </a:rPr>
-              <a:t>Sum present values to arrive at intrinsic firm or equity value.</a:t>
+              <a:t>Driver-based models are more defensible and easier to stress-test.</a:t>
             </a:r>
             <a:endParaRPr lang="en-US" sz="1500" dirty="0"/>
           </a:p>
@@ -3492,7 +4171,7 @@
                 <a:ea typeface="Arial" pitchFamily="34" charset="-122"/>
                 <a:cs typeface="Arial" pitchFamily="34" charset="-120"/>
               </a:rPr>
-              <a:t>DCF valuation follows a disciplined four-input, step-by-step sequence that converts projected performance into intrinsic value.</a:t>
+              <a:t>A clean, revenue-driven FCFF model is the foundation of any credible DCF valuation.</a:t>
             </a:r>
             <a:endParaRPr lang="en-US" sz="1100" dirty="0"/>
           </a:p>
@@ -3583,7 +4262,7 @@
                 <a:ea typeface="Arial" pitchFamily="34" charset="-122"/>
                 <a:cs typeface="Arial" pitchFamily="34" charset="-120"/>
               </a:rPr>
-              <a:t>DCF Valuation: Standard Procedure</a:t>
+              <a:t>DCF Valuation: Step-by-Step Process</a:t>
             </a:r>
             <a:endParaRPr lang="en-US" sz="2000" dirty="0"/>
           </a:p>
@@ -3622,7 +4301,7 @@
                 <a:ea typeface="Arial" pitchFamily="34" charset="-122"/>
                 <a:cs typeface="Arial" pitchFamily="34" charset="-120"/>
               </a:rPr>
-              <a:t>Each step feeds the next; input errors compound dramatically across all periods</a:t>
+              <a:t>Each step feeds the next; changing revenue growth ripples through the entire model</a:t>
             </a:r>
             <a:endParaRPr lang="en-US" sz="1000" dirty="0"/>
           </a:p>
@@ -3768,7 +4447,7 @@
                 <a:ea typeface="Arial" pitchFamily="34" charset="-122"/>
                 <a:cs typeface="Arial" pitchFamily="34" charset="-120"/>
               </a:rPr>
-              <a:t>Forecast Free Cash Flows</a:t>
+              <a:t>Project Revenue</a:t>
             </a:r>
             <a:endParaRPr lang="en-US" sz="1200" dirty="0"/>
           </a:p>
@@ -3807,7 +4486,7 @@
                 <a:ea typeface="Arial" pitchFamily="34" charset="-122"/>
                 <a:cs typeface="Arial" pitchFamily="34" charset="-120"/>
               </a:rPr>
-              <a:t>Project FCFs for 5–10 year explicit horizon</a:t>
+              <a:t>Drive COGS, SG&amp;A, D&amp;A from revenue growth</a:t>
             </a:r>
             <a:endParaRPr lang="en-US" sz="900" dirty="0"/>
           </a:p>
@@ -3934,7 +4613,7 @@
                 <a:ea typeface="Arial" pitchFamily="34" charset="-122"/>
                 <a:cs typeface="Arial" pitchFamily="34" charset="-120"/>
               </a:rPr>
-              <a:t>Estimate Terminal Value</a:t>
+              <a:t>Calculate FCFF</a:t>
             </a:r>
             <a:endParaRPr lang="en-US" sz="1200" dirty="0"/>
           </a:p>
@@ -3973,7 +4652,7 @@
                 <a:ea typeface="Arial" pitchFamily="34" charset="-122"/>
                 <a:cs typeface="Arial" pitchFamily="34" charset="-120"/>
               </a:rPr>
-              <a:t>Use Gordon Growth Model beyond forecast period</a:t>
+              <a:t>EBIT×(1−Tax)+D&amp;A−CapEx−ΔNWC</a:t>
             </a:r>
             <a:endParaRPr lang="en-US" sz="900" dirty="0"/>
           </a:p>
@@ -4100,7 +4779,7 @@
                 <a:ea typeface="Arial" pitchFamily="34" charset="-122"/>
                 <a:cs typeface="Arial" pitchFamily="34" charset="-120"/>
               </a:rPr>
-              <a:t>Discount Each FCF</a:t>
+              <a:t>Compute WACC</a:t>
             </a:r>
             <a:endParaRPr lang="en-US" sz="1200" dirty="0"/>
           </a:p>
@@ -4139,7 +4818,7 @@
                 <a:ea typeface="Arial" pitchFamily="34" charset="-122"/>
                 <a:cs typeface="Arial" pitchFamily="34" charset="-120"/>
               </a:rPr>
-              <a:t>Divide each FCF by (1+r)^t individually</a:t>
+              <a:t>Blend after-tax cost of debt and equity</a:t>
             </a:r>
             <a:endParaRPr lang="en-US" sz="900" dirty="0"/>
           </a:p>
@@ -4266,7 +4945,7 @@
                 <a:ea typeface="Arial" pitchFamily="34" charset="-122"/>
                 <a:cs typeface="Arial" pitchFamily="34" charset="-120"/>
               </a:rPr>
-              <a:t>Discount Terminal Value</a:t>
+              <a:t>Discount Cash Flows</a:t>
             </a:r>
             <a:endParaRPr lang="en-US" sz="1200" dirty="0"/>
           </a:p>
@@ -4305,7 +4984,7 @@
                 <a:ea typeface="Arial" pitchFamily="34" charset="-122"/>
                 <a:cs typeface="Arial" pitchFamily="34" charset="-120"/>
               </a:rPr>
-              <a:t>Bring TV back to present using (1+r)^n</a:t>
+              <a:t>Divide each FCFF by (1+WACC)^t</a:t>
             </a:r>
             <a:endParaRPr lang="en-US" sz="900" dirty="0"/>
           </a:p>
@@ -4432,7 +5111,7 @@
                 <a:ea typeface="Arial" pitchFamily="34" charset="-122"/>
                 <a:cs typeface="Arial" pitchFamily="34" charset="-120"/>
               </a:rPr>
-              <a:t>Sum All Present Values</a:t>
+              <a:t>Add Terminal Value</a:t>
             </a:r>
             <a:endParaRPr lang="en-US" sz="1200" dirty="0"/>
           </a:p>
@@ -4471,7 +5150,7 @@
                 <a:ea typeface="Arial" pitchFamily="34" charset="-122"/>
                 <a:cs typeface="Arial" pitchFamily="34" charset="-120"/>
               </a:rPr>
-              <a:t>Total equals enterprise value or project NPV</a:t>
+              <a:t>Capture value beyond explicit forecast period</a:t>
             </a:r>
             <a:endParaRPr lang="en-US" sz="900" dirty="0"/>
           </a:p>
@@ -4598,7 +5277,7 @@
                 <a:ea typeface="Arial" pitchFamily="34" charset="-122"/>
                 <a:cs typeface="Arial" pitchFamily="34" charset="-120"/>
               </a:rPr>
-              <a:t>Bridge to Equity Value</a:t>
+              <a:t>Enterprise Value</a:t>
             </a:r>
             <a:endParaRPr lang="en-US" sz="1200" dirty="0"/>
           </a:p>
@@ -4637,7 +5316,7 @@
                 <a:ea typeface="Arial" pitchFamily="34" charset="-122"/>
                 <a:cs typeface="Arial" pitchFamily="34" charset="-120"/>
               </a:rPr>
-              <a:t>Subtract net debt, add cash if needed</a:t>
+              <a:t>Sum of all discounted cash flows</a:t>
             </a:r>
             <a:endParaRPr lang="en-US" sz="900" dirty="0"/>
           </a:p>
@@ -4728,7 +5407,7 @@
                 <a:ea typeface="Arial" pitchFamily="34" charset="-122"/>
                 <a:cs typeface="Arial" pitchFamily="34" charset="-120"/>
               </a:rPr>
-              <a:t>DCF Applications and Pitfalls</a:t>
+              <a:t>Calculating WACC as the DCF Discount Rate</a:t>
             </a:r>
             <a:endParaRPr lang="en-US" sz="2100" dirty="0"/>
           </a:p>
@@ -4833,7 +5512,7 @@
                 <a:ea typeface="Arial" pitchFamily="34" charset="-122"/>
                 <a:cs typeface="Arial" pitchFamily="34" charset="-120"/>
               </a:rPr>
-              <a:t>Used in equity valuation, M&amp;A, capital budgeting, and real estate.</a:t>
+              <a:t>WACC = (E/V) × Ke + (D/V) × Kd × (1 − t).</a:t>
             </a:r>
             <a:endParaRPr lang="en-US" sz="1500" dirty="0"/>
           </a:p>
@@ -4854,7 +5533,7 @@
                 <a:ea typeface="Arial" pitchFamily="34" charset="-122"/>
                 <a:cs typeface="Arial" pitchFamily="34" charset="-120"/>
               </a:rPr>
-              <a:t>Terminal value often represents 60–80% of total estimated value.</a:t>
+              <a:t>Weights must use market values, not outdated book values.</a:t>
             </a:r>
             <a:endParaRPr lang="en-US" sz="1500" dirty="0"/>
           </a:p>
@@ -4875,7 +5554,7 @@
                 <a:ea typeface="Arial" pitchFamily="34" charset="-122"/>
                 <a:cs typeface="Arial" pitchFamily="34" charset="-120"/>
               </a:rPr>
-              <a:t>Never mix nominal cash flows with a real discount rate.</a:t>
+              <a:t>Cost of equity estimated via CAPM: Ke = Rf + β × (Rm − Rf).</a:t>
             </a:r>
             <a:endParaRPr lang="en-US" sz="1500" dirty="0"/>
           </a:p>
@@ -4896,7 +5575,7 @@
                 <a:ea typeface="Arial" pitchFamily="34" charset="-122"/>
                 <a:cs typeface="Arial" pitchFamily="34" charset="-120"/>
               </a:rPr>
-              <a:t>Free cash flow excludes net income shortcuts—capex and NWC matter.</a:t>
+              <a:t>Pre-tax cost of debt is tax-adjusted because interest is deductible.</a:t>
             </a:r>
             <a:endParaRPr lang="en-US" sz="1500" dirty="0"/>
           </a:p>
@@ -4917,7 +5596,7 @@
                 <a:ea typeface="Arial" pitchFamily="34" charset="-122"/>
                 <a:cs typeface="Arial" pitchFamily="34" charset="-120"/>
               </a:rPr>
-              <a:t>Terminal growth above long-run GDP growth demands heavy scrutiny.</a:t>
+              <a:t>Every input must be grounded in current, observable market data.</a:t>
             </a:r>
             <a:endParaRPr lang="en-US" sz="1500" dirty="0"/>
           </a:p>
@@ -4999,7 +5678,7 @@
                 <a:ea typeface="Arial" pitchFamily="34" charset="-122"/>
                 <a:cs typeface="Arial" pitchFamily="34" charset="-120"/>
               </a:rPr>
-              <a:t>DCF is widely applicable but easily misused; the terminal value assumption and cash flow definition are the highest-risk inputs.</a:t>
+              <a:t>WACC is a precisely constructed required return, not a guess, and every component demands rigorous market-based support.</a:t>
             </a:r>
             <a:endParaRPr lang="en-US" sz="1100" dirty="0"/>
           </a:p>
@@ -5045,8 +5724,8 @@
         </p:nvSpPr>
         <p:spPr>
           <a:xfrm>
-            <a:off x="411480" y="384048"/>
-            <a:ext cx="82296" cy="310896"/>
+            <a:off x="411480" y="402336"/>
+            <a:ext cx="82296" cy="329184"/>
           </a:xfrm>
           <a:prstGeom prst="rect">
             <a:avLst/>
@@ -5066,7 +5745,7 @@
         <p:spPr>
           <a:xfrm>
             <a:off x="566928" y="292608"/>
-            <a:ext cx="8138160" cy="502920"/>
+            <a:ext cx="8138160" cy="548640"/>
           </a:xfrm>
           <a:prstGeom prst="rect">
             <a:avLst/>
@@ -5082,7 +5761,7 @@
               <a:buNone/>
             </a:pPr>
             <a:r>
-              <a:rPr lang="en-US" sz="2000" b="1" dirty="0">
+              <a:rPr lang="en-US" sz="2100" b="1" dirty="0">
                 <a:solidFill>
                   <a:srgbClr val="1C1917"/>
                 </a:solidFill>
@@ -5090,100 +5769,22 @@
                 <a:ea typeface="Arial" pitchFamily="34" charset="-122"/>
                 <a:cs typeface="Arial" pitchFamily="34" charset="-120"/>
               </a:rPr>
-              <a:t>Nominal vs. Discounted Cash Flows (10%)</a:t>
-            </a:r>
-            <a:endParaRPr lang="en-US" sz="2000" dirty="0"/>
-          </a:p>
-        </p:txBody>
-      </p:sp>
-      <p:sp>
-        <p:nvSpPr>
-          <p:cNvPr id="4" name="Text 2"/>
-          <p:cNvSpPr/>
-          <p:nvPr/>
-        </p:nvSpPr>
-        <p:spPr>
-          <a:xfrm>
-            <a:off x="566928" y="4681728"/>
-            <a:ext cx="8138160" cy="320040"/>
-          </a:xfrm>
-          <a:prstGeom prst="rect">
-            <a:avLst/>
-          </a:prstGeom>
-          <a:noFill/>
-          <a:ln/>
-        </p:spPr>
-        <p:txBody>
-          <a:bodyPr wrap="square" rtlCol="0" anchor="ctr"/>
-          <a:lstStyle/>
-          <a:p>
-            <a:pPr indent="0" marL="0">
-              <a:buNone/>
-            </a:pPr>
-            <a:r>
-              <a:rPr lang="en-US" sz="1000" i="1" dirty="0">
-                <a:solidFill>
-                  <a:srgbClr val="78716C"/>
-                </a:solidFill>
-                <a:latin typeface="Arial" pitchFamily="34" charset="0"/>
-                <a:ea typeface="Arial" pitchFamily="34" charset="-122"/>
-                <a:cs typeface="Arial" pitchFamily="34" charset="-120"/>
-              </a:rPr>
-              <a:t>Nominal total $53,000 vs. NPV $43,538 — $9,461 is the measurable cost of waiting</a:t>
-            </a:r>
-            <a:endParaRPr lang="en-US" sz="1000" dirty="0"/>
-          </a:p>
-        </p:txBody>
-      </p:sp>
-      <p:sp>
-        <p:nvSpPr>
-          <p:cNvPr id="5" name="Text 3"/>
-          <p:cNvSpPr/>
-          <p:nvPr/>
-        </p:nvSpPr>
-        <p:spPr>
-          <a:xfrm>
-            <a:off x="411480" y="4919472"/>
-            <a:ext cx="8321040" cy="219456"/>
-          </a:xfrm>
-          <a:prstGeom prst="rect">
-            <a:avLst/>
-          </a:prstGeom>
-          <a:noFill/>
-          <a:ln/>
-        </p:spPr>
-        <p:txBody>
-          <a:bodyPr wrap="square" rtlCol="0" anchor="ctr"/>
-          <a:lstStyle/>
-          <a:p>
-            <a:pPr indent="0" marL="0">
-              <a:buNone/>
-            </a:pPr>
-            <a:r>
-              <a:rPr lang="en-US" sz="750" dirty="0">
-                <a:solidFill>
-                  <a:srgbClr val="AAAAAA"/>
-                </a:solidFill>
-                <a:latin typeface="Arial" pitchFamily="34" charset="0"/>
-                <a:ea typeface="Arial" pitchFamily="34" charset="-122"/>
-                <a:cs typeface="Arial" pitchFamily="34" charset="-120"/>
-              </a:rPr>
-              <a:t>Lesson Forge Pro (owner) — This content is educational material only and does not constitute financial, investment, or trading advice.</a:t>
-            </a:r>
-            <a:endParaRPr lang="en-US" sz="750" dirty="0"/>
-          </a:p>
-        </p:txBody>
-      </p:sp>
-      <p:sp>
-        <p:nvSpPr>
-          <p:cNvPr id="6" name="Shape 4"/>
-          <p:cNvSpPr/>
-          <p:nvPr/>
-        </p:nvSpPr>
-        <p:spPr>
-          <a:xfrm>
-            <a:off x="685800" y="4206240"/>
-            <a:ext cx="7772400" cy="0"/>
+              <a:t>Terminal Value: Gordon Growth Model and Exit Multiple Methods</a:t>
+            </a:r>
+            <a:endParaRPr lang="en-US" sz="2100" dirty="0"/>
+          </a:p>
+        </p:txBody>
+      </p:sp>
+      <p:sp>
+        <p:nvSpPr>
+          <p:cNvPr id="4" name="Shape 2"/>
+          <p:cNvSpPr/>
+          <p:nvPr/>
+        </p:nvSpPr>
+        <p:spPr>
+          <a:xfrm>
+            <a:off x="411480" y="960120"/>
+            <a:ext cx="8321040" cy="0"/>
           </a:xfrm>
           <a:prstGeom prst="line">
             <a:avLst/>
@@ -5191,7 +5792,7 @@
           <a:noFill/>
           <a:ln w="12700">
             <a:solidFill>
-              <a:srgbClr val="1C1917"/>
+              <a:srgbClr val="E7E5E4"/>
             </a:solidFill>
             <a:prstDash val="solid"/>
           </a:ln>
@@ -5199,22 +5800,197 @@
       </p:sp>
       <p:sp>
         <p:nvSpPr>
+          <p:cNvPr id="5" name="Text 3"/>
+          <p:cNvSpPr/>
+          <p:nvPr/>
+        </p:nvSpPr>
+        <p:spPr>
+          <a:xfrm>
+            <a:off x="411480" y="4864608"/>
+            <a:ext cx="8321040" cy="237744"/>
+          </a:xfrm>
+          <a:prstGeom prst="rect">
+            <a:avLst/>
+          </a:prstGeom>
+          <a:noFill/>
+          <a:ln/>
+        </p:spPr>
+        <p:txBody>
+          <a:bodyPr wrap="square" rtlCol="0" anchor="ctr"/>
+          <a:lstStyle/>
+          <a:p>
+            <a:pPr indent="0" marL="0">
+              <a:buNone/>
+            </a:pPr>
+            <a:r>
+              <a:rPr lang="en-US" sz="750" dirty="0">
+                <a:solidFill>
+                  <a:srgbClr val="AAAAAA"/>
+                </a:solidFill>
+                <a:latin typeface="Arial" pitchFamily="34" charset="0"/>
+                <a:ea typeface="Arial" pitchFamily="34" charset="-122"/>
+                <a:cs typeface="Arial" pitchFamily="34" charset="-120"/>
+              </a:rPr>
+              <a:t>Lesson Forge Pro (owner) — This content is educational material only and does not constitute financial, investment, or trading advice.</a:t>
+            </a:r>
+            <a:endParaRPr lang="en-US" sz="750" dirty="0"/>
+          </a:p>
+        </p:txBody>
+      </p:sp>
+      <p:sp>
+        <p:nvSpPr>
+          <p:cNvPr id="6" name="Text 4"/>
+          <p:cNvSpPr/>
+          <p:nvPr/>
+        </p:nvSpPr>
+        <p:spPr>
+          <a:xfrm>
+            <a:off x="731520" y="1188720"/>
+            <a:ext cx="7680960" cy="2743200"/>
+          </a:xfrm>
+          <a:prstGeom prst="rect">
+            <a:avLst/>
+          </a:prstGeom>
+          <a:noFill/>
+          <a:ln/>
+        </p:spPr>
+        <p:txBody>
+          <a:bodyPr wrap="square" rtlCol="0" anchor="t"/>
+          <a:lstStyle/>
+          <a:p>
+            <a:pPr marL="152400" indent="-152400">
+              <a:spcAft>
+                <a:spcPts val="800"/>
+              </a:spcAft>
+              <a:buSzPct val="100000"/>
+              <a:buChar char="•"/>
+            </a:pPr>
+            <a:r>
+              <a:rPr lang="en-US" sz="1500" dirty="0">
+                <a:solidFill>
+                  <a:srgbClr val="1C1917"/>
+                </a:solidFill>
+                <a:latin typeface="Arial" pitchFamily="34" charset="0"/>
+                <a:ea typeface="Arial" pitchFamily="34" charset="-122"/>
+                <a:cs typeface="Arial" pitchFamily="34" charset="-120"/>
+              </a:rPr>
+              <a:t>Terminal value typically represents 60–80% of total enterprise value.</a:t>
+            </a:r>
+            <a:endParaRPr lang="en-US" sz="1500" dirty="0"/>
+          </a:p>
+          <a:p>
+            <a:pPr marL="152400" indent="-152400">
+              <a:spcAft>
+                <a:spcPts val="800"/>
+              </a:spcAft>
+              <a:buSzPct val="100000"/>
+              <a:buChar char="•"/>
+            </a:pPr>
+            <a:r>
+              <a:rPr lang="en-US" sz="1500" dirty="0">
+                <a:solidFill>
+                  <a:srgbClr val="1C1917"/>
+                </a:solidFill>
+                <a:latin typeface="Arial" pitchFamily="34" charset="0"/>
+                <a:ea typeface="Arial" pitchFamily="34" charset="-122"/>
+                <a:cs typeface="Arial" pitchFamily="34" charset="-120"/>
+              </a:rPr>
+              <a:t>Gordon Growth Model: TV = FCF × (1 + g) / (WACC − g).</a:t>
+            </a:r>
+            <a:endParaRPr lang="en-US" sz="1500" dirty="0"/>
+          </a:p>
+          <a:p>
+            <a:pPr marL="152400" indent="-152400">
+              <a:spcAft>
+                <a:spcPts val="800"/>
+              </a:spcAft>
+              <a:buSzPct val="100000"/>
+              <a:buChar char="•"/>
+            </a:pPr>
+            <a:r>
+              <a:rPr lang="en-US" sz="1500" dirty="0">
+                <a:solidFill>
+                  <a:srgbClr val="1C1917"/>
+                </a:solidFill>
+                <a:latin typeface="Arial" pitchFamily="34" charset="0"/>
+                <a:ea typeface="Arial" pitchFamily="34" charset="-122"/>
+                <a:cs typeface="Arial" pitchFamily="34" charset="-120"/>
+              </a:rPr>
+              <a:t>Exit Multiple Method applies an industry multiple to a final-year metric.</a:t>
+            </a:r>
+            <a:endParaRPr lang="en-US" sz="1500" dirty="0"/>
+          </a:p>
+          <a:p>
+            <a:pPr marL="152400" indent="-152400">
+              <a:spcAft>
+                <a:spcPts val="800"/>
+              </a:spcAft>
+              <a:buSzPct val="100000"/>
+              <a:buChar char="•"/>
+            </a:pPr>
+            <a:r>
+              <a:rPr lang="en-US" sz="1500" dirty="0">
+                <a:solidFill>
+                  <a:srgbClr val="1C1917"/>
+                </a:solidFill>
+                <a:latin typeface="Arial" pitchFamily="34" charset="0"/>
+                <a:ea typeface="Arial" pitchFamily="34" charset="-122"/>
+                <a:cs typeface="Arial" pitchFamily="34" charset="-120"/>
+              </a:rPr>
+              <a:t>Growth rate g must stay below long-run GDP growth to be credible.</a:t>
+            </a:r>
+            <a:endParaRPr lang="en-US" sz="1500" dirty="0"/>
+          </a:p>
+          <a:p>
+            <a:pPr marL="152400" indent="-152400">
+              <a:spcAft>
+                <a:spcPts val="800"/>
+              </a:spcAft>
+              <a:buSzPct val="100000"/>
+              <a:buChar char="•"/>
+            </a:pPr>
+            <a:r>
+              <a:rPr lang="en-US" sz="1500" dirty="0">
+                <a:solidFill>
+                  <a:srgbClr val="1C1917"/>
+                </a:solidFill>
+                <a:latin typeface="Arial" pitchFamily="34" charset="0"/>
+                <a:ea typeface="Arial" pitchFamily="34" charset="-122"/>
+                <a:cs typeface="Arial" pitchFamily="34" charset="-120"/>
+              </a:rPr>
+              <a:t>Always cross-check both methods; large divergence signals a flawed assumption.</a:t>
+            </a:r>
+            <a:endParaRPr lang="en-US" sz="1500" dirty="0"/>
+          </a:p>
+        </p:txBody>
+      </p:sp>
+      <p:sp>
+        <p:nvSpPr>
           <p:cNvPr id="7" name="Shape 5"/>
           <p:cNvSpPr/>
           <p:nvPr/>
         </p:nvSpPr>
         <p:spPr>
           <a:xfrm>
-            <a:off x="1059180" y="2011680"/>
-            <a:ext cx="777240" cy="2194560"/>
-          </a:xfrm>
-          <a:prstGeom prst="rect">
-            <a:avLst/>
+            <a:off x="731520" y="4041648"/>
+            <a:ext cx="7680960" cy="566928"/>
+          </a:xfrm>
+          <a:prstGeom prst="roundRect">
+            <a:avLst>
+              <a:gd name="adj" fmla="val 12903"/>
+            </a:avLst>
           </a:prstGeom>
           <a:solidFill>
-            <a:srgbClr val="B45309"/>
+            <a:srgbClr val="B45309">
+              <a:alpha val="12000"/>
+            </a:srgbClr>
           </a:solidFill>
-          <a:ln/>
+          <a:ln w="12700">
+            <a:solidFill>
+              <a:srgbClr val="B45309"/>
+            </a:solidFill>
+            <a:prstDash val="solid"/>
+          </a:ln>
         </p:spPr>
       </p:sp>
       <p:sp>
@@ -5225,8 +6001,8 @@
         </p:nvSpPr>
         <p:spPr>
           <a:xfrm>
-            <a:off x="876300" y="1737360"/>
-            <a:ext cx="1143000" cy="237744"/>
+            <a:off x="868680" y="4087368"/>
+            <a:ext cx="7406640" cy="475488"/>
           </a:xfrm>
           <a:prstGeom prst="rect">
             <a:avLst/>
@@ -5238,11 +6014,25 @@
           <a:bodyPr wrap="square" rtlCol="0" anchor="ctr"/>
           <a:lstStyle/>
           <a:p>
-            <a:pPr algn="ctr" indent="0" marL="0">
-              <a:buNone/>
-            </a:pPr>
-            <a:r>
-              <a:rPr lang="en-US" sz="950" b="1" dirty="0">
+            <a:pPr indent="0" marL="0">
+              <a:buNone/>
+            </a:pPr>
+            <a:r>
+              <a:rPr lang="en-US" sz="1100" b="1" dirty="0">
+                <a:solidFill>
+                  <a:srgbClr val="B45309"/>
+                </a:solidFill>
+                <a:latin typeface="Arial" pitchFamily="34" charset="0"/>
+                <a:ea typeface="Arial" pitchFamily="34" charset="-122"/>
+                <a:cs typeface="Arial" pitchFamily="34" charset="-120"/>
+              </a:rPr>
+              <a:t>Takeaway  </a:t>
+            </a:r>
+            <a:pPr indent="0" marL="0">
+              <a:buNone/>
+            </a:pPr>
+            <a:r>
+              <a:rPr lang="en-US" sz="1150" dirty="0">
                 <a:solidFill>
                   <a:srgbClr val="1C1917"/>
                 </a:solidFill>
@@ -5250,538 +6040,9 @@
                 <a:ea typeface="Arial" pitchFamily="34" charset="-122"/>
                 <a:cs typeface="Arial" pitchFamily="34" charset="-120"/>
               </a:rPr>
-              <a:t>15000</a:t>
-            </a:r>
-            <a:endParaRPr lang="en-US" sz="950" dirty="0"/>
-          </a:p>
-        </p:txBody>
-      </p:sp>
-      <p:sp>
-        <p:nvSpPr>
-          <p:cNvPr id="9" name="Text 7"/>
-          <p:cNvSpPr/>
-          <p:nvPr/>
-        </p:nvSpPr>
-        <p:spPr>
-          <a:xfrm>
-            <a:off x="830580" y="4315968"/>
-            <a:ext cx="1234440" cy="502920"/>
-          </a:xfrm>
-          <a:prstGeom prst="rect">
-            <a:avLst/>
-          </a:prstGeom>
-          <a:noFill/>
-          <a:ln/>
-        </p:spPr>
-        <p:txBody>
-          <a:bodyPr wrap="square" rtlCol="0" anchor="ctr"/>
-          <a:lstStyle/>
-          <a:p>
-            <a:pPr algn="ctr" indent="0" marL="0">
-              <a:buNone/>
-            </a:pPr>
-            <a:r>
-              <a:rPr lang="en-US" sz="850" dirty="0">
-                <a:solidFill>
-                  <a:srgbClr val="78716C"/>
-                </a:solidFill>
-                <a:latin typeface="Arial" pitchFamily="34" charset="0"/>
-                <a:ea typeface="Arial" pitchFamily="34" charset="-122"/>
-                <a:cs typeface="Arial" pitchFamily="34" charset="-120"/>
-              </a:rPr>
-              <a:t>Year 1 Nominal</a:t>
-            </a:r>
-            <a:endParaRPr lang="en-US" sz="850" dirty="0"/>
-          </a:p>
-        </p:txBody>
-      </p:sp>
-      <p:sp>
-        <p:nvSpPr>
-          <p:cNvPr id="10" name="Shape 8"/>
-          <p:cNvSpPr/>
-          <p:nvPr/>
-        </p:nvSpPr>
-        <p:spPr>
-          <a:xfrm>
-            <a:off x="2308860" y="2211239"/>
-            <a:ext cx="777240" cy="1995001"/>
-          </a:xfrm>
-          <a:prstGeom prst="rect">
-            <a:avLst/>
-          </a:prstGeom>
-          <a:solidFill>
-            <a:srgbClr val="B45309"/>
-          </a:solidFill>
-          <a:ln/>
-        </p:spPr>
-      </p:sp>
-      <p:sp>
-        <p:nvSpPr>
-          <p:cNvPr id="11" name="Text 9"/>
-          <p:cNvSpPr/>
-          <p:nvPr/>
-        </p:nvSpPr>
-        <p:spPr>
-          <a:xfrm>
-            <a:off x="2125980" y="1936919"/>
-            <a:ext cx="1143000" cy="237744"/>
-          </a:xfrm>
-          <a:prstGeom prst="rect">
-            <a:avLst/>
-          </a:prstGeom>
-          <a:noFill/>
-          <a:ln/>
-        </p:spPr>
-        <p:txBody>
-          <a:bodyPr wrap="square" rtlCol="0" anchor="ctr"/>
-          <a:lstStyle/>
-          <a:p>
-            <a:pPr algn="ctr" indent="0" marL="0">
-              <a:buNone/>
-            </a:pPr>
-            <a:r>
-              <a:rPr lang="en-US" sz="950" b="1" dirty="0">
-                <a:solidFill>
-                  <a:srgbClr val="1C1917"/>
-                </a:solidFill>
-                <a:latin typeface="Arial" pitchFamily="34" charset="0"/>
-                <a:ea typeface="Arial" pitchFamily="34" charset="-122"/>
-                <a:cs typeface="Arial" pitchFamily="34" charset="-120"/>
-              </a:rPr>
-              <a:t>13636</a:t>
-            </a:r>
-            <a:endParaRPr lang="en-US" sz="950" dirty="0"/>
-          </a:p>
-        </p:txBody>
-      </p:sp>
-      <p:sp>
-        <p:nvSpPr>
-          <p:cNvPr id="12" name="Text 10"/>
-          <p:cNvSpPr/>
-          <p:nvPr/>
-        </p:nvSpPr>
-        <p:spPr>
-          <a:xfrm>
-            <a:off x="2080260" y="4315968"/>
-            <a:ext cx="1234440" cy="502920"/>
-          </a:xfrm>
-          <a:prstGeom prst="rect">
-            <a:avLst/>
-          </a:prstGeom>
-          <a:noFill/>
-          <a:ln/>
-        </p:spPr>
-        <p:txBody>
-          <a:bodyPr wrap="square" rtlCol="0" anchor="ctr"/>
-          <a:lstStyle/>
-          <a:p>
-            <a:pPr algn="ctr" indent="0" marL="0">
-              <a:buNone/>
-            </a:pPr>
-            <a:r>
-              <a:rPr lang="en-US" sz="850" dirty="0">
-                <a:solidFill>
-                  <a:srgbClr val="78716C"/>
-                </a:solidFill>
-                <a:latin typeface="Arial" pitchFamily="34" charset="0"/>
-                <a:ea typeface="Arial" pitchFamily="34" charset="-122"/>
-                <a:cs typeface="Arial" pitchFamily="34" charset="-120"/>
-              </a:rPr>
-              <a:t>Year 1 Discounted</a:t>
-            </a:r>
-            <a:endParaRPr lang="en-US" sz="850" dirty="0"/>
-          </a:p>
-        </p:txBody>
-      </p:sp>
-      <p:sp>
-        <p:nvSpPr>
-          <p:cNvPr id="13" name="Shape 11"/>
-          <p:cNvSpPr/>
-          <p:nvPr/>
-        </p:nvSpPr>
-        <p:spPr>
-          <a:xfrm>
-            <a:off x="3558540" y="1572768"/>
-            <a:ext cx="777240" cy="2633472"/>
-          </a:xfrm>
-          <a:prstGeom prst="rect">
-            <a:avLst/>
-          </a:prstGeom>
-          <a:solidFill>
-            <a:srgbClr val="B45309"/>
-          </a:solidFill>
-          <a:ln/>
-        </p:spPr>
-      </p:sp>
-      <p:sp>
-        <p:nvSpPr>
-          <p:cNvPr id="14" name="Text 12"/>
-          <p:cNvSpPr/>
-          <p:nvPr/>
-        </p:nvSpPr>
-        <p:spPr>
-          <a:xfrm>
-            <a:off x="3375660" y="1298448"/>
-            <a:ext cx="1143000" cy="237744"/>
-          </a:xfrm>
-          <a:prstGeom prst="rect">
-            <a:avLst/>
-          </a:prstGeom>
-          <a:noFill/>
-          <a:ln/>
-        </p:spPr>
-        <p:txBody>
-          <a:bodyPr wrap="square" rtlCol="0" anchor="ctr"/>
-          <a:lstStyle/>
-          <a:p>
-            <a:pPr algn="ctr" indent="0" marL="0">
-              <a:buNone/>
-            </a:pPr>
-            <a:r>
-              <a:rPr lang="en-US" sz="950" b="1" dirty="0">
-                <a:solidFill>
-                  <a:srgbClr val="1C1917"/>
-                </a:solidFill>
-                <a:latin typeface="Arial" pitchFamily="34" charset="0"/>
-                <a:ea typeface="Arial" pitchFamily="34" charset="-122"/>
-                <a:cs typeface="Arial" pitchFamily="34" charset="-120"/>
-              </a:rPr>
-              <a:t>18000</a:t>
-            </a:r>
-            <a:endParaRPr lang="en-US" sz="950" dirty="0"/>
-          </a:p>
-        </p:txBody>
-      </p:sp>
-      <p:sp>
-        <p:nvSpPr>
-          <p:cNvPr id="15" name="Text 13"/>
-          <p:cNvSpPr/>
-          <p:nvPr/>
-        </p:nvSpPr>
-        <p:spPr>
-          <a:xfrm>
-            <a:off x="3329940" y="4315968"/>
-            <a:ext cx="1234440" cy="502920"/>
-          </a:xfrm>
-          <a:prstGeom prst="rect">
-            <a:avLst/>
-          </a:prstGeom>
-          <a:noFill/>
-          <a:ln/>
-        </p:spPr>
-        <p:txBody>
-          <a:bodyPr wrap="square" rtlCol="0" anchor="ctr"/>
-          <a:lstStyle/>
-          <a:p>
-            <a:pPr algn="ctr" indent="0" marL="0">
-              <a:buNone/>
-            </a:pPr>
-            <a:r>
-              <a:rPr lang="en-US" sz="850" dirty="0">
-                <a:solidFill>
-                  <a:srgbClr val="78716C"/>
-                </a:solidFill>
-                <a:latin typeface="Arial" pitchFamily="34" charset="0"/>
-                <a:ea typeface="Arial" pitchFamily="34" charset="-122"/>
-                <a:cs typeface="Arial" pitchFamily="34" charset="-120"/>
-              </a:rPr>
-              <a:t>Year 2 Nominal</a:t>
-            </a:r>
-            <a:endParaRPr lang="en-US" sz="850" dirty="0"/>
-          </a:p>
-        </p:txBody>
-      </p:sp>
-      <p:sp>
-        <p:nvSpPr>
-          <p:cNvPr id="16" name="Shape 14"/>
-          <p:cNvSpPr/>
-          <p:nvPr/>
-        </p:nvSpPr>
-        <p:spPr>
-          <a:xfrm>
-            <a:off x="4808220" y="2029822"/>
-            <a:ext cx="777240" cy="2176418"/>
-          </a:xfrm>
-          <a:prstGeom prst="rect">
-            <a:avLst/>
-          </a:prstGeom>
-          <a:solidFill>
-            <a:srgbClr val="B45309"/>
-          </a:solidFill>
-          <a:ln/>
-        </p:spPr>
-      </p:sp>
-      <p:sp>
-        <p:nvSpPr>
-          <p:cNvPr id="17" name="Text 15"/>
-          <p:cNvSpPr/>
-          <p:nvPr/>
-        </p:nvSpPr>
-        <p:spPr>
-          <a:xfrm>
-            <a:off x="4625340" y="1755502"/>
-            <a:ext cx="1143000" cy="237744"/>
-          </a:xfrm>
-          <a:prstGeom prst="rect">
-            <a:avLst/>
-          </a:prstGeom>
-          <a:noFill/>
-          <a:ln/>
-        </p:spPr>
-        <p:txBody>
-          <a:bodyPr wrap="square" rtlCol="0" anchor="ctr"/>
-          <a:lstStyle/>
-          <a:p>
-            <a:pPr algn="ctr" indent="0" marL="0">
-              <a:buNone/>
-            </a:pPr>
-            <a:r>
-              <a:rPr lang="en-US" sz="950" b="1" dirty="0">
-                <a:solidFill>
-                  <a:srgbClr val="1C1917"/>
-                </a:solidFill>
-                <a:latin typeface="Arial" pitchFamily="34" charset="0"/>
-                <a:ea typeface="Arial" pitchFamily="34" charset="-122"/>
-                <a:cs typeface="Arial" pitchFamily="34" charset="-120"/>
-              </a:rPr>
-              <a:t>14876</a:t>
-            </a:r>
-            <a:endParaRPr lang="en-US" sz="950" dirty="0"/>
-          </a:p>
-        </p:txBody>
-      </p:sp>
-      <p:sp>
-        <p:nvSpPr>
-          <p:cNvPr id="18" name="Text 16"/>
-          <p:cNvSpPr/>
-          <p:nvPr/>
-        </p:nvSpPr>
-        <p:spPr>
-          <a:xfrm>
-            <a:off x="4579620" y="4315968"/>
-            <a:ext cx="1234440" cy="502920"/>
-          </a:xfrm>
-          <a:prstGeom prst="rect">
-            <a:avLst/>
-          </a:prstGeom>
-          <a:noFill/>
-          <a:ln/>
-        </p:spPr>
-        <p:txBody>
-          <a:bodyPr wrap="square" rtlCol="0" anchor="ctr"/>
-          <a:lstStyle/>
-          <a:p>
-            <a:pPr algn="ctr" indent="0" marL="0">
-              <a:buNone/>
-            </a:pPr>
-            <a:r>
-              <a:rPr lang="en-US" sz="850" dirty="0">
-                <a:solidFill>
-                  <a:srgbClr val="78716C"/>
-                </a:solidFill>
-                <a:latin typeface="Arial" pitchFamily="34" charset="0"/>
-                <a:ea typeface="Arial" pitchFamily="34" charset="-122"/>
-                <a:cs typeface="Arial" pitchFamily="34" charset="-120"/>
-              </a:rPr>
-              <a:t>Year 2 Discounted</a:t>
-            </a:r>
-            <a:endParaRPr lang="en-US" sz="850" dirty="0"/>
-          </a:p>
-        </p:txBody>
-      </p:sp>
-      <p:sp>
-        <p:nvSpPr>
-          <p:cNvPr id="19" name="Shape 17"/>
-          <p:cNvSpPr/>
-          <p:nvPr/>
-        </p:nvSpPr>
-        <p:spPr>
-          <a:xfrm>
-            <a:off x="6057900" y="1280160"/>
-            <a:ext cx="777240" cy="2926080"/>
-          </a:xfrm>
-          <a:prstGeom prst="rect">
-            <a:avLst/>
-          </a:prstGeom>
-          <a:solidFill>
-            <a:srgbClr val="B45309"/>
-          </a:solidFill>
-          <a:ln/>
-        </p:spPr>
-      </p:sp>
-      <p:sp>
-        <p:nvSpPr>
-          <p:cNvPr id="20" name="Text 18"/>
-          <p:cNvSpPr/>
-          <p:nvPr/>
-        </p:nvSpPr>
-        <p:spPr>
-          <a:xfrm>
-            <a:off x="5875020" y="1005840"/>
-            <a:ext cx="1143000" cy="237744"/>
-          </a:xfrm>
-          <a:prstGeom prst="rect">
-            <a:avLst/>
-          </a:prstGeom>
-          <a:noFill/>
-          <a:ln/>
-        </p:spPr>
-        <p:txBody>
-          <a:bodyPr wrap="square" rtlCol="0" anchor="ctr"/>
-          <a:lstStyle/>
-          <a:p>
-            <a:pPr algn="ctr" indent="0" marL="0">
-              <a:buNone/>
-            </a:pPr>
-            <a:r>
-              <a:rPr lang="en-US" sz="950" b="1" dirty="0">
-                <a:solidFill>
-                  <a:srgbClr val="1C1917"/>
-                </a:solidFill>
-                <a:latin typeface="Arial" pitchFamily="34" charset="0"/>
-                <a:ea typeface="Arial" pitchFamily="34" charset="-122"/>
-                <a:cs typeface="Arial" pitchFamily="34" charset="-120"/>
-              </a:rPr>
-              <a:t>20000</a:t>
-            </a:r>
-            <a:endParaRPr lang="en-US" sz="950" dirty="0"/>
-          </a:p>
-        </p:txBody>
-      </p:sp>
-      <p:sp>
-        <p:nvSpPr>
-          <p:cNvPr id="21" name="Text 19"/>
-          <p:cNvSpPr/>
-          <p:nvPr/>
-        </p:nvSpPr>
-        <p:spPr>
-          <a:xfrm>
-            <a:off x="5829300" y="4315968"/>
-            <a:ext cx="1234440" cy="502920"/>
-          </a:xfrm>
-          <a:prstGeom prst="rect">
-            <a:avLst/>
-          </a:prstGeom>
-          <a:noFill/>
-          <a:ln/>
-        </p:spPr>
-        <p:txBody>
-          <a:bodyPr wrap="square" rtlCol="0" anchor="ctr"/>
-          <a:lstStyle/>
-          <a:p>
-            <a:pPr algn="ctr" indent="0" marL="0">
-              <a:buNone/>
-            </a:pPr>
-            <a:r>
-              <a:rPr lang="en-US" sz="850" dirty="0">
-                <a:solidFill>
-                  <a:srgbClr val="78716C"/>
-                </a:solidFill>
-                <a:latin typeface="Arial" pitchFamily="34" charset="0"/>
-                <a:ea typeface="Arial" pitchFamily="34" charset="-122"/>
-                <a:cs typeface="Arial" pitchFamily="34" charset="-120"/>
-              </a:rPr>
-              <a:t>Year 3 Nominal</a:t>
-            </a:r>
-            <a:endParaRPr lang="en-US" sz="850" dirty="0"/>
-          </a:p>
-        </p:txBody>
-      </p:sp>
-      <p:sp>
-        <p:nvSpPr>
-          <p:cNvPr id="22" name="Shape 20"/>
-          <p:cNvSpPr/>
-          <p:nvPr/>
-        </p:nvSpPr>
-        <p:spPr>
-          <a:xfrm>
-            <a:off x="7307580" y="2007876"/>
-            <a:ext cx="777240" cy="2198364"/>
-          </a:xfrm>
-          <a:prstGeom prst="rect">
-            <a:avLst/>
-          </a:prstGeom>
-          <a:solidFill>
-            <a:srgbClr val="B45309"/>
-          </a:solidFill>
-          <a:ln/>
-        </p:spPr>
-      </p:sp>
-      <p:sp>
-        <p:nvSpPr>
-          <p:cNvPr id="23" name="Text 21"/>
-          <p:cNvSpPr/>
-          <p:nvPr/>
-        </p:nvSpPr>
-        <p:spPr>
-          <a:xfrm>
-            <a:off x="7124700" y="1733556"/>
-            <a:ext cx="1143000" cy="237744"/>
-          </a:xfrm>
-          <a:prstGeom prst="rect">
-            <a:avLst/>
-          </a:prstGeom>
-          <a:noFill/>
-          <a:ln/>
-        </p:spPr>
-        <p:txBody>
-          <a:bodyPr wrap="square" rtlCol="0" anchor="ctr"/>
-          <a:lstStyle/>
-          <a:p>
-            <a:pPr algn="ctr" indent="0" marL="0">
-              <a:buNone/>
-            </a:pPr>
-            <a:r>
-              <a:rPr lang="en-US" sz="950" b="1" dirty="0">
-                <a:solidFill>
-                  <a:srgbClr val="1C1917"/>
-                </a:solidFill>
-                <a:latin typeface="Arial" pitchFamily="34" charset="0"/>
-                <a:ea typeface="Arial" pitchFamily="34" charset="-122"/>
-                <a:cs typeface="Arial" pitchFamily="34" charset="-120"/>
-              </a:rPr>
-              <a:t>15026</a:t>
-            </a:r>
-            <a:endParaRPr lang="en-US" sz="950" dirty="0"/>
-          </a:p>
-        </p:txBody>
-      </p:sp>
-      <p:sp>
-        <p:nvSpPr>
-          <p:cNvPr id="24" name="Text 22"/>
-          <p:cNvSpPr/>
-          <p:nvPr/>
-        </p:nvSpPr>
-        <p:spPr>
-          <a:xfrm>
-            <a:off x="7078980" y="4315968"/>
-            <a:ext cx="1234440" cy="502920"/>
-          </a:xfrm>
-          <a:prstGeom prst="rect">
-            <a:avLst/>
-          </a:prstGeom>
-          <a:noFill/>
-          <a:ln/>
-        </p:spPr>
-        <p:txBody>
-          <a:bodyPr wrap="square" rtlCol="0" anchor="ctr"/>
-          <a:lstStyle/>
-          <a:p>
-            <a:pPr algn="ctr" indent="0" marL="0">
-              <a:buNone/>
-            </a:pPr>
-            <a:r>
-              <a:rPr lang="en-US" sz="850" dirty="0">
-                <a:solidFill>
-                  <a:srgbClr val="78716C"/>
-                </a:solidFill>
-                <a:latin typeface="Arial" pitchFamily="34" charset="0"/>
-                <a:ea typeface="Arial" pitchFamily="34" charset="-122"/>
-                <a:cs typeface="Arial" pitchFamily="34" charset="-120"/>
-              </a:rPr>
-              <a:t>Year 3 Discounted</a:t>
-            </a:r>
-            <a:endParaRPr lang="en-US" sz="850" dirty="0"/>
+              <a:t>Terminal value dominates DCF results, so choosing and cross-checking your method carefully is non-negotiable.</a:t>
+            </a:r>
+            <a:endParaRPr lang="en-US" sz="1100" dirty="0"/>
           </a:p>
         </p:txBody>
       </p:sp>
@@ -5825,8 +6086,8 @@
         </p:nvSpPr>
         <p:spPr>
           <a:xfrm>
-            <a:off x="411480" y="402336"/>
-            <a:ext cx="82296" cy="329184"/>
+            <a:off x="411480" y="384048"/>
+            <a:ext cx="82296" cy="310896"/>
           </a:xfrm>
           <a:prstGeom prst="rect">
             <a:avLst/>
@@ -5846,7 +6107,7 @@
         <p:spPr>
           <a:xfrm>
             <a:off x="566928" y="292608"/>
-            <a:ext cx="8138160" cy="548640"/>
+            <a:ext cx="8138160" cy="502920"/>
           </a:xfrm>
           <a:prstGeom prst="rect">
             <a:avLst/>
@@ -5862,7 +6123,7 @@
               <a:buNone/>
             </a:pPr>
             <a:r>
-              <a:rPr lang="en-US" sz="2100" b="1" dirty="0">
+              <a:rPr lang="en-US" sz="2000" b="1" dirty="0">
                 <a:solidFill>
                   <a:srgbClr val="1C1917"/>
                 </a:solidFill>
@@ -5870,22 +6131,100 @@
                 <a:ea typeface="Arial" pitchFamily="34" charset="-122"/>
                 <a:cs typeface="Arial" pitchFamily="34" charset="-120"/>
               </a:rPr>
-              <a:t>Worked Example: Correcting a Flawed DCF</a:t>
-            </a:r>
-            <a:endParaRPr lang="en-US" sz="2100" dirty="0"/>
-          </a:p>
-        </p:txBody>
-      </p:sp>
-      <p:sp>
-        <p:nvSpPr>
-          <p:cNvPr id="4" name="Shape 2"/>
-          <p:cNvSpPr/>
-          <p:nvPr/>
-        </p:nvSpPr>
-        <p:spPr>
-          <a:xfrm>
-            <a:off x="411480" y="960120"/>
-            <a:ext cx="8321040" cy="0"/>
+              <a:t>Present Value Erosion Over Time (10% Rate)</a:t>
+            </a:r>
+            <a:endParaRPr lang="en-US" sz="2000" dirty="0"/>
+          </a:p>
+        </p:txBody>
+      </p:sp>
+      <p:sp>
+        <p:nvSpPr>
+          <p:cNvPr id="4" name="Text 2"/>
+          <p:cNvSpPr/>
+          <p:nvPr/>
+        </p:nvSpPr>
+        <p:spPr>
+          <a:xfrm>
+            <a:off x="566928" y="4681728"/>
+            <a:ext cx="8138160" cy="320040"/>
+          </a:xfrm>
+          <a:prstGeom prst="rect">
+            <a:avLst/>
+          </a:prstGeom>
+          <a:noFill/>
+          <a:ln/>
+        </p:spPr>
+        <p:txBody>
+          <a:bodyPr wrap="square" rtlCol="0" anchor="ctr"/>
+          <a:lstStyle/>
+          <a:p>
+            <a:pPr indent="0" marL="0">
+              <a:buNone/>
+            </a:pPr>
+            <a:r>
+              <a:rPr lang="en-US" sz="1000" i="1" dirty="0">
+                <a:solidFill>
+                  <a:srgbClr val="78716C"/>
+                </a:solidFill>
+                <a:latin typeface="Arial" pitchFamily="34" charset="0"/>
+                <a:ea typeface="Arial" pitchFamily="34" charset="-122"/>
+                <a:cs typeface="Arial" pitchFamily="34" charset="-120"/>
+              </a:rPr>
+              <a:t>Each additional year at 10% discount rate reduces present value by roughly $40,000</a:t>
+            </a:r>
+            <a:endParaRPr lang="en-US" sz="1000" dirty="0"/>
+          </a:p>
+        </p:txBody>
+      </p:sp>
+      <p:sp>
+        <p:nvSpPr>
+          <p:cNvPr id="5" name="Text 3"/>
+          <p:cNvSpPr/>
+          <p:nvPr/>
+        </p:nvSpPr>
+        <p:spPr>
+          <a:xfrm>
+            <a:off x="411480" y="4919472"/>
+            <a:ext cx="8321040" cy="219456"/>
+          </a:xfrm>
+          <a:prstGeom prst="rect">
+            <a:avLst/>
+          </a:prstGeom>
+          <a:noFill/>
+          <a:ln/>
+        </p:spPr>
+        <p:txBody>
+          <a:bodyPr wrap="square" rtlCol="0" anchor="ctr"/>
+          <a:lstStyle/>
+          <a:p>
+            <a:pPr indent="0" marL="0">
+              <a:buNone/>
+            </a:pPr>
+            <a:r>
+              <a:rPr lang="en-US" sz="750" dirty="0">
+                <a:solidFill>
+                  <a:srgbClr val="AAAAAA"/>
+                </a:solidFill>
+                <a:latin typeface="Arial" pitchFamily="34" charset="0"/>
+                <a:ea typeface="Arial" pitchFamily="34" charset="-122"/>
+                <a:cs typeface="Arial" pitchFamily="34" charset="-120"/>
+              </a:rPr>
+              <a:t>Lesson Forge Pro (owner) — This content is educational material only and does not constitute financial, investment, or trading advice.</a:t>
+            </a:r>
+            <a:endParaRPr lang="en-US" sz="750" dirty="0"/>
+          </a:p>
+        </p:txBody>
+      </p:sp>
+      <p:sp>
+        <p:nvSpPr>
+          <p:cNvPr id="6" name="Shape 4"/>
+          <p:cNvSpPr/>
+          <p:nvPr/>
+        </p:nvSpPr>
+        <p:spPr>
+          <a:xfrm>
+            <a:off x="685800" y="4206240"/>
+            <a:ext cx="7772400" cy="0"/>
           </a:xfrm>
           <a:prstGeom prst="line">
             <a:avLst/>
@@ -5893,7 +6232,7 @@
           <a:noFill/>
           <a:ln w="12700">
             <a:solidFill>
-              <a:srgbClr val="E7E5E4"/>
+              <a:srgbClr val="1C1917"/>
             </a:solidFill>
             <a:prstDash val="solid"/>
           </a:ln>
@@ -5901,14 +6240,34 @@
       </p:sp>
       <p:sp>
         <p:nvSpPr>
-          <p:cNvPr id="5" name="Text 3"/>
-          <p:cNvSpPr/>
-          <p:nvPr/>
-        </p:nvSpPr>
-        <p:spPr>
-          <a:xfrm>
-            <a:off x="411480" y="4864608"/>
-            <a:ext cx="8321040" cy="237744"/>
+          <p:cNvPr id="7" name="Shape 5"/>
+          <p:cNvSpPr/>
+          <p:nvPr/>
+        </p:nvSpPr>
+        <p:spPr>
+          <a:xfrm>
+            <a:off x="1371600" y="1280160"/>
+            <a:ext cx="777240" cy="2926080"/>
+          </a:xfrm>
+          <a:prstGeom prst="rect">
+            <a:avLst/>
+          </a:prstGeom>
+          <a:solidFill>
+            <a:srgbClr val="B45309"/>
+          </a:solidFill>
+          <a:ln/>
+        </p:spPr>
+      </p:sp>
+      <p:sp>
+        <p:nvSpPr>
+          <p:cNvPr id="8" name="Text 6"/>
+          <p:cNvSpPr/>
+          <p:nvPr/>
+        </p:nvSpPr>
+        <p:spPr>
+          <a:xfrm>
+            <a:off x="1188720" y="1005840"/>
+            <a:ext cx="1143000" cy="237744"/>
           </a:xfrm>
           <a:prstGeom prst="rect">
             <a:avLst/>
@@ -5920,54 +6279,11 @@
           <a:bodyPr wrap="square" rtlCol="0" anchor="ctr"/>
           <a:lstStyle/>
           <a:p>
-            <a:pPr indent="0" marL="0">
-              <a:buNone/>
-            </a:pPr>
-            <a:r>
-              <a:rPr lang="en-US" sz="750" dirty="0">
-                <a:solidFill>
-                  <a:srgbClr val="AAAAAA"/>
-                </a:solidFill>
-                <a:latin typeface="Arial" pitchFamily="34" charset="0"/>
-                <a:ea typeface="Arial" pitchFamily="34" charset="-122"/>
-                <a:cs typeface="Arial" pitchFamily="34" charset="-120"/>
-              </a:rPr>
-              <a:t>Lesson Forge Pro (owner) — This content is educational material only and does not constitute financial, investment, or trading advice.</a:t>
-            </a:r>
-            <a:endParaRPr lang="en-US" sz="750" dirty="0"/>
-          </a:p>
-        </p:txBody>
-      </p:sp>
-      <p:sp>
-        <p:nvSpPr>
-          <p:cNvPr id="6" name="Text 4"/>
-          <p:cNvSpPr/>
-          <p:nvPr/>
-        </p:nvSpPr>
-        <p:spPr>
-          <a:xfrm>
-            <a:off x="731520" y="1188720"/>
-            <a:ext cx="7680960" cy="2743200"/>
-          </a:xfrm>
-          <a:prstGeom prst="rect">
-            <a:avLst/>
-          </a:prstGeom>
-          <a:noFill/>
-          <a:ln/>
-        </p:spPr>
-        <p:txBody>
-          <a:bodyPr wrap="square" rtlCol="0" anchor="t"/>
-          <a:lstStyle/>
-          <a:p>
-            <a:pPr marL="152400" indent="-152400">
-              <a:spcAft>
-                <a:spcPts val="800"/>
-              </a:spcAft>
-              <a:buSzPct val="100000"/>
-              <a:buChar char="•"/>
-            </a:pPr>
-            <a:r>
-              <a:rPr lang="en-US" sz="1500" dirty="0">
+            <a:pPr algn="ctr" indent="0" marL="0">
+              <a:buNone/>
+            </a:pPr>
+            <a:r>
+              <a:rPr lang="en-US" sz="950" b="1" dirty="0">
                 <a:solidFill>
                   <a:srgbClr val="1C1917"/>
                 </a:solidFill>
@@ -5975,20 +6291,97 @@
                 <a:ea typeface="Arial" pitchFamily="34" charset="-122"/>
                 <a:cs typeface="Arial" pitchFamily="34" charset="-120"/>
               </a:rPr>
-              <a:t>Wrong: using EBITDA directly as free cash flow overstates value.</a:t>
-            </a:r>
-            <a:endParaRPr lang="en-US" sz="1500" dirty="0"/>
-          </a:p>
-          <a:p>
-            <a:pPr marL="152400" indent="-152400">
-              <a:spcAft>
-                <a:spcPts val="800"/>
-              </a:spcAft>
-              <a:buSzPct val="100000"/>
-              <a:buChar char="•"/>
-            </a:pPr>
-            <a:r>
-              <a:rPr lang="en-US" sz="1500" dirty="0">
+              <a:t>500000</a:t>
+            </a:r>
+            <a:endParaRPr lang="en-US" sz="950" dirty="0"/>
+          </a:p>
+        </p:txBody>
+      </p:sp>
+      <p:sp>
+        <p:nvSpPr>
+          <p:cNvPr id="9" name="Text 7"/>
+          <p:cNvSpPr/>
+          <p:nvPr/>
+        </p:nvSpPr>
+        <p:spPr>
+          <a:xfrm>
+            <a:off x="1143000" y="4315968"/>
+            <a:ext cx="1234440" cy="502920"/>
+          </a:xfrm>
+          <a:prstGeom prst="rect">
+            <a:avLst/>
+          </a:prstGeom>
+          <a:noFill/>
+          <a:ln/>
+        </p:spPr>
+        <p:txBody>
+          <a:bodyPr wrap="square" rtlCol="0" anchor="ctr"/>
+          <a:lstStyle/>
+          <a:p>
+            <a:pPr algn="ctr" indent="0" marL="0">
+              <a:buNone/>
+            </a:pPr>
+            <a:r>
+              <a:rPr lang="en-US" sz="850" dirty="0">
+                <a:solidFill>
+                  <a:srgbClr val="78716C"/>
+                </a:solidFill>
+                <a:latin typeface="Arial" pitchFamily="34" charset="0"/>
+                <a:ea typeface="Arial" pitchFamily="34" charset="-122"/>
+                <a:cs typeface="Arial" pitchFamily="34" charset="-120"/>
+              </a:rPr>
+              <a:t>Year 0 (FV)</a:t>
+            </a:r>
+            <a:endParaRPr lang="en-US" sz="850" dirty="0"/>
+          </a:p>
+        </p:txBody>
+      </p:sp>
+      <p:sp>
+        <p:nvSpPr>
+          <p:cNvPr id="10" name="Shape 8"/>
+          <p:cNvSpPr/>
+          <p:nvPr/>
+        </p:nvSpPr>
+        <p:spPr>
+          <a:xfrm>
+            <a:off x="3246120" y="1546170"/>
+            <a:ext cx="777240" cy="2660070"/>
+          </a:xfrm>
+          <a:prstGeom prst="rect">
+            <a:avLst/>
+          </a:prstGeom>
+          <a:solidFill>
+            <a:srgbClr val="B45309"/>
+          </a:solidFill>
+          <a:ln/>
+        </p:spPr>
+      </p:sp>
+      <p:sp>
+        <p:nvSpPr>
+          <p:cNvPr id="11" name="Text 9"/>
+          <p:cNvSpPr/>
+          <p:nvPr/>
+        </p:nvSpPr>
+        <p:spPr>
+          <a:xfrm>
+            <a:off x="3063240" y="1271850"/>
+            <a:ext cx="1143000" cy="237744"/>
+          </a:xfrm>
+          <a:prstGeom prst="rect">
+            <a:avLst/>
+          </a:prstGeom>
+          <a:noFill/>
+          <a:ln/>
+        </p:spPr>
+        <p:txBody>
+          <a:bodyPr wrap="square" rtlCol="0" anchor="ctr"/>
+          <a:lstStyle/>
+          <a:p>
+            <a:pPr algn="ctr" indent="0" marL="0">
+              <a:buNone/>
+            </a:pPr>
+            <a:r>
+              <a:rPr lang="en-US" sz="950" b="1" dirty="0">
                 <a:solidFill>
                   <a:srgbClr val="1C1917"/>
                 </a:solidFill>
@@ -5996,20 +6389,97 @@
                 <a:ea typeface="Arial" pitchFamily="34" charset="-122"/>
                 <a:cs typeface="Arial" pitchFamily="34" charset="-120"/>
               </a:rPr>
-              <a:t>Correct FCF = EBITDA×(1−tax) − net capex − change in NWC.</a:t>
-            </a:r>
-            <a:endParaRPr lang="en-US" sz="1500" dirty="0"/>
-          </a:p>
-          <a:p>
-            <a:pPr marL="152400" indent="-152400">
-              <a:spcAft>
-                <a:spcPts val="800"/>
-              </a:spcAft>
-              <a:buSzPct val="100000"/>
-              <a:buChar char="•"/>
-            </a:pPr>
-            <a:r>
-              <a:rPr lang="en-US" sz="1500" dirty="0">
+              <a:t>454545</a:t>
+            </a:r>
+            <a:endParaRPr lang="en-US" sz="950" dirty="0"/>
+          </a:p>
+        </p:txBody>
+      </p:sp>
+      <p:sp>
+        <p:nvSpPr>
+          <p:cNvPr id="12" name="Text 10"/>
+          <p:cNvSpPr/>
+          <p:nvPr/>
+        </p:nvSpPr>
+        <p:spPr>
+          <a:xfrm>
+            <a:off x="3017520" y="4315968"/>
+            <a:ext cx="1234440" cy="502920"/>
+          </a:xfrm>
+          <a:prstGeom prst="rect">
+            <a:avLst/>
+          </a:prstGeom>
+          <a:noFill/>
+          <a:ln/>
+        </p:spPr>
+        <p:txBody>
+          <a:bodyPr wrap="square" rtlCol="0" anchor="ctr"/>
+          <a:lstStyle/>
+          <a:p>
+            <a:pPr algn="ctr" indent="0" marL="0">
+              <a:buNone/>
+            </a:pPr>
+            <a:r>
+              <a:rPr lang="en-US" sz="850" dirty="0">
+                <a:solidFill>
+                  <a:srgbClr val="78716C"/>
+                </a:solidFill>
+                <a:latin typeface="Arial" pitchFamily="34" charset="0"/>
+                <a:ea typeface="Arial" pitchFamily="34" charset="-122"/>
+                <a:cs typeface="Arial" pitchFamily="34" charset="-120"/>
+              </a:rPr>
+              <a:t>Year 1 PV</a:t>
+            </a:r>
+            <a:endParaRPr lang="en-US" sz="850" dirty="0"/>
+          </a:p>
+        </p:txBody>
+      </p:sp>
+      <p:sp>
+        <p:nvSpPr>
+          <p:cNvPr id="13" name="Shape 11"/>
+          <p:cNvSpPr/>
+          <p:nvPr/>
+        </p:nvSpPr>
+        <p:spPr>
+          <a:xfrm>
+            <a:off x="5120640" y="1787993"/>
+            <a:ext cx="777240" cy="2418247"/>
+          </a:xfrm>
+          <a:prstGeom prst="rect">
+            <a:avLst/>
+          </a:prstGeom>
+          <a:solidFill>
+            <a:srgbClr val="B45309"/>
+          </a:solidFill>
+          <a:ln/>
+        </p:spPr>
+      </p:sp>
+      <p:sp>
+        <p:nvSpPr>
+          <p:cNvPr id="14" name="Text 12"/>
+          <p:cNvSpPr/>
+          <p:nvPr/>
+        </p:nvSpPr>
+        <p:spPr>
+          <a:xfrm>
+            <a:off x="4937760" y="1513673"/>
+            <a:ext cx="1143000" cy="237744"/>
+          </a:xfrm>
+          <a:prstGeom prst="rect">
+            <a:avLst/>
+          </a:prstGeom>
+          <a:noFill/>
+          <a:ln/>
+        </p:spPr>
+        <p:txBody>
+          <a:bodyPr wrap="square" rtlCol="0" anchor="ctr"/>
+          <a:lstStyle/>
+          <a:p>
+            <a:pPr algn="ctr" indent="0" marL="0">
+              <a:buNone/>
+            </a:pPr>
+            <a:r>
+              <a:rPr lang="en-US" sz="950" b="1" dirty="0">
                 <a:solidFill>
                   <a:srgbClr val="1C1917"/>
                 </a:solidFill>
@@ -6017,20 +6487,97 @@
                 <a:ea typeface="Arial" pitchFamily="34" charset="-122"/>
                 <a:cs typeface="Arial" pitchFamily="34" charset="-120"/>
               </a:rPr>
-              <a:t>Example firm: $500K EBITDA yields $315K correct FCF, not $500K.</a:t>
-            </a:r>
-            <a:endParaRPr lang="en-US" sz="1500" dirty="0"/>
-          </a:p>
-          <a:p>
-            <a:pPr marL="152400" indent="-152400">
-              <a:spcAft>
-                <a:spcPts val="800"/>
-              </a:spcAft>
-              <a:buSzPct val="100000"/>
-              <a:buChar char="•"/>
-            </a:pPr>
-            <a:r>
-              <a:rPr lang="en-US" sz="1500" dirty="0">
+              <a:t>413223</a:t>
+            </a:r>
+            <a:endParaRPr lang="en-US" sz="950" dirty="0"/>
+          </a:p>
+        </p:txBody>
+      </p:sp>
+      <p:sp>
+        <p:nvSpPr>
+          <p:cNvPr id="15" name="Text 13"/>
+          <p:cNvSpPr/>
+          <p:nvPr/>
+        </p:nvSpPr>
+        <p:spPr>
+          <a:xfrm>
+            <a:off x="4892040" y="4315968"/>
+            <a:ext cx="1234440" cy="502920"/>
+          </a:xfrm>
+          <a:prstGeom prst="rect">
+            <a:avLst/>
+          </a:prstGeom>
+          <a:noFill/>
+          <a:ln/>
+        </p:spPr>
+        <p:txBody>
+          <a:bodyPr wrap="square" rtlCol="0" anchor="ctr"/>
+          <a:lstStyle/>
+          <a:p>
+            <a:pPr algn="ctr" indent="0" marL="0">
+              <a:buNone/>
+            </a:pPr>
+            <a:r>
+              <a:rPr lang="en-US" sz="850" dirty="0">
+                <a:solidFill>
+                  <a:srgbClr val="78716C"/>
+                </a:solidFill>
+                <a:latin typeface="Arial" pitchFamily="34" charset="0"/>
+                <a:ea typeface="Arial" pitchFamily="34" charset="-122"/>
+                <a:cs typeface="Arial" pitchFamily="34" charset="-120"/>
+              </a:rPr>
+              <a:t>Year 2 PV</a:t>
+            </a:r>
+            <a:endParaRPr lang="en-US" sz="850" dirty="0"/>
+          </a:p>
+        </p:txBody>
+      </p:sp>
+      <p:sp>
+        <p:nvSpPr>
+          <p:cNvPr id="16" name="Shape 14"/>
+          <p:cNvSpPr/>
+          <p:nvPr/>
+        </p:nvSpPr>
+        <p:spPr>
+          <a:xfrm>
+            <a:off x="6995160" y="2007835"/>
+            <a:ext cx="777240" cy="2198405"/>
+          </a:xfrm>
+          <a:prstGeom prst="rect">
+            <a:avLst/>
+          </a:prstGeom>
+          <a:solidFill>
+            <a:srgbClr val="B45309"/>
+          </a:solidFill>
+          <a:ln/>
+        </p:spPr>
+      </p:sp>
+      <p:sp>
+        <p:nvSpPr>
+          <p:cNvPr id="17" name="Text 15"/>
+          <p:cNvSpPr/>
+          <p:nvPr/>
+        </p:nvSpPr>
+        <p:spPr>
+          <a:xfrm>
+            <a:off x="6812280" y="1733515"/>
+            <a:ext cx="1143000" cy="237744"/>
+          </a:xfrm>
+          <a:prstGeom prst="rect">
+            <a:avLst/>
+          </a:prstGeom>
+          <a:noFill/>
+          <a:ln/>
+        </p:spPr>
+        <p:txBody>
+          <a:bodyPr wrap="square" rtlCol="0" anchor="ctr"/>
+          <a:lstStyle/>
+          <a:p>
+            <a:pPr algn="ctr" indent="0" marL="0">
+              <a:buNone/>
+            </a:pPr>
+            <a:r>
+              <a:rPr lang="en-US" sz="950" b="1" dirty="0">
                 <a:solidFill>
                   <a:srgbClr val="1C1917"/>
                 </a:solidFill>
@@ -6038,72 +6585,22 @@
                 <a:ea typeface="Arial" pitchFamily="34" charset="-122"/>
                 <a:cs typeface="Arial" pitchFamily="34" charset="-120"/>
               </a:rPr>
-              <a:t>Terminal growth of 6% far exceeds GDP—must be reduced.</a:t>
-            </a:r>
-            <a:endParaRPr lang="en-US" sz="1500" dirty="0"/>
-          </a:p>
-          <a:p>
-            <a:pPr marL="152400" indent="-152400">
-              <a:spcAft>
-                <a:spcPts val="800"/>
-              </a:spcAft>
-              <a:buSzPct val="100000"/>
-              <a:buChar char="•"/>
-            </a:pPr>
-            <a:r>
-              <a:rPr lang="en-US" sz="1500" dirty="0">
-                <a:solidFill>
-                  <a:srgbClr val="1C1917"/>
-                </a:solidFill>
-                <a:latin typeface="Arial" pitchFamily="34" charset="0"/>
-                <a:ea typeface="Arial" pitchFamily="34" charset="-122"/>
-                <a:cs typeface="Arial" pitchFamily="34" charset="-120"/>
-              </a:rPr>
-              <a:t>Each fix compounds: errors in FCF and growth rate stack quickly.</a:t>
-            </a:r>
-            <a:endParaRPr lang="en-US" sz="1500" dirty="0"/>
-          </a:p>
-        </p:txBody>
-      </p:sp>
-      <p:sp>
-        <p:nvSpPr>
-          <p:cNvPr id="7" name="Shape 5"/>
-          <p:cNvSpPr/>
-          <p:nvPr/>
-        </p:nvSpPr>
-        <p:spPr>
-          <a:xfrm>
-            <a:off x="731520" y="4041648"/>
-            <a:ext cx="7680960" cy="566928"/>
-          </a:xfrm>
-          <a:prstGeom prst="roundRect">
-            <a:avLst>
-              <a:gd name="adj" fmla="val 12903"/>
-            </a:avLst>
-          </a:prstGeom>
-          <a:solidFill>
-            <a:srgbClr val="B45309">
-              <a:alpha val="12000"/>
-            </a:srgbClr>
-          </a:solidFill>
-          <a:ln w="12700">
-            <a:solidFill>
-              <a:srgbClr val="B45309"/>
-            </a:solidFill>
-            <a:prstDash val="solid"/>
-          </a:ln>
-        </p:spPr>
-      </p:sp>
-      <p:sp>
-        <p:nvSpPr>
-          <p:cNvPr id="8" name="Text 6"/>
-          <p:cNvSpPr/>
-          <p:nvPr/>
-        </p:nvSpPr>
-        <p:spPr>
-          <a:xfrm>
-            <a:off x="868680" y="4087368"/>
-            <a:ext cx="7406640" cy="475488"/>
+              <a:t>375657</a:t>
+            </a:r>
+            <a:endParaRPr lang="en-US" sz="950" dirty="0"/>
+          </a:p>
+        </p:txBody>
+      </p:sp>
+      <p:sp>
+        <p:nvSpPr>
+          <p:cNvPr id="18" name="Text 16"/>
+          <p:cNvSpPr/>
+          <p:nvPr/>
+        </p:nvSpPr>
+        <p:spPr>
+          <a:xfrm>
+            <a:off x="6766560" y="4315968"/>
+            <a:ext cx="1234440" cy="502920"/>
           </a:xfrm>
           <a:prstGeom prst="rect">
             <a:avLst/>
@@ -6115,35 +6612,21 @@
           <a:bodyPr wrap="square" rtlCol="0" anchor="ctr"/>
           <a:lstStyle/>
           <a:p>
-            <a:pPr indent="0" marL="0">
-              <a:buNone/>
-            </a:pPr>
-            <a:r>
-              <a:rPr lang="en-US" sz="1100" b="1" dirty="0">
-                <a:solidFill>
-                  <a:srgbClr val="B45309"/>
-                </a:solidFill>
-                <a:latin typeface="Arial" pitchFamily="34" charset="0"/>
-                <a:ea typeface="Arial" pitchFamily="34" charset="-122"/>
-                <a:cs typeface="Arial" pitchFamily="34" charset="-120"/>
-              </a:rPr>
-              <a:t>Takeaway  </a:t>
-            </a:r>
-            <a:pPr indent="0" marL="0">
-              <a:buNone/>
-            </a:pPr>
-            <a:r>
-              <a:rPr lang="en-US" sz="1150" dirty="0">
-                <a:solidFill>
-                  <a:srgbClr val="1C1917"/>
-                </a:solidFill>
-                <a:latin typeface="Arial" pitchFamily="34" charset="0"/>
-                <a:ea typeface="Arial" pitchFamily="34" charset="-122"/>
-                <a:cs typeface="Arial" pitchFamily="34" charset="-120"/>
-              </a:rPr>
-              <a:t>A single flawed input—wrong FCF definition or an unrealistic growth rate—can dramatically distort a DCF conclusion.</a:t>
-            </a:r>
-            <a:endParaRPr lang="en-US" sz="1100" dirty="0"/>
+            <a:pPr algn="ctr" indent="0" marL="0">
+              <a:buNone/>
+            </a:pPr>
+            <a:r>
+              <a:rPr lang="en-US" sz="850" dirty="0">
+                <a:solidFill>
+                  <a:srgbClr val="78716C"/>
+                </a:solidFill>
+                <a:latin typeface="Arial" pitchFamily="34" charset="0"/>
+                <a:ea typeface="Arial" pitchFamily="34" charset="-122"/>
+                <a:cs typeface="Arial" pitchFamily="34" charset="-120"/>
+              </a:rPr>
+              <a:t>Year 3 PV</a:t>
+            </a:r>
+            <a:endParaRPr lang="en-US" sz="850" dirty="0"/>
           </a:p>
         </p:txBody>
       </p:sp>
@@ -6187,8 +6670,8 @@
         </p:nvSpPr>
         <p:spPr>
           <a:xfrm>
-            <a:off x="411480" y="384048"/>
-            <a:ext cx="82296" cy="310896"/>
+            <a:off x="411480" y="402336"/>
+            <a:ext cx="82296" cy="329184"/>
           </a:xfrm>
           <a:prstGeom prst="rect">
             <a:avLst/>
@@ -6208,7 +6691,7 @@
         <p:spPr>
           <a:xfrm>
             <a:off x="566928" y="292608"/>
-            <a:ext cx="8138160" cy="502920"/>
+            <a:ext cx="8138160" cy="548640"/>
           </a:xfrm>
           <a:prstGeom prst="rect">
             <a:avLst/>
@@ -6224,7 +6707,7 @@
               <a:buNone/>
             </a:pPr>
             <a:r>
-              <a:rPr lang="en-US" sz="2000" b="1" dirty="0">
+              <a:rPr lang="en-US" sz="2100" b="1" dirty="0">
                 <a:solidFill>
                   <a:srgbClr val="1C1917"/>
                 </a:solidFill>
@@ -6232,110 +6715,30 @@
                 <a:ea typeface="Arial" pitchFamily="34" charset="-122"/>
                 <a:cs typeface="Arial" pitchFamily="34" charset="-120"/>
               </a:rPr>
-              <a:t>DCF Applicability: Risk vs. Market Data</a:t>
-            </a:r>
-            <a:endParaRPr lang="en-US" sz="2000" dirty="0"/>
-          </a:p>
-        </p:txBody>
-      </p:sp>
-      <p:sp>
-        <p:nvSpPr>
-          <p:cNvPr id="4" name="Text 2"/>
-          <p:cNvSpPr/>
-          <p:nvPr/>
-        </p:nvSpPr>
-        <p:spPr>
-          <a:xfrm>
-            <a:off x="566928" y="4681728"/>
-            <a:ext cx="8138160" cy="320040"/>
-          </a:xfrm>
-          <a:prstGeom prst="rect">
-            <a:avLst/>
-          </a:prstGeom>
-          <a:noFill/>
-          <a:ln/>
-        </p:spPr>
-        <p:txBody>
-          <a:bodyPr wrap="square" rtlCol="0" anchor="ctr"/>
-          <a:lstStyle/>
-          <a:p>
-            <a:pPr indent="0" marL="0">
-              <a:buNone/>
-            </a:pPr>
-            <a:r>
-              <a:rPr lang="en-US" sz="1000" i="1" dirty="0">
-                <a:solidFill>
-                  <a:srgbClr val="78716C"/>
-                </a:solidFill>
-                <a:latin typeface="Arial" pitchFamily="34" charset="0"/>
-                <a:ea typeface="Arial" pitchFamily="34" charset="-122"/>
-                <a:cs typeface="Arial" pitchFamily="34" charset="-120"/>
-              </a:rPr>
-              <a:t>DCF is most indispensable when comparable market data are scarce or unreliable</a:t>
-            </a:r>
-            <a:endParaRPr lang="en-US" sz="1000" dirty="0"/>
-          </a:p>
-        </p:txBody>
-      </p:sp>
-      <p:sp>
-        <p:nvSpPr>
-          <p:cNvPr id="5" name="Text 3"/>
-          <p:cNvSpPr/>
-          <p:nvPr/>
-        </p:nvSpPr>
-        <p:spPr>
-          <a:xfrm>
-            <a:off x="411480" y="4919472"/>
-            <a:ext cx="8321040" cy="219456"/>
-          </a:xfrm>
-          <a:prstGeom prst="rect">
-            <a:avLst/>
-          </a:prstGeom>
-          <a:noFill/>
-          <a:ln/>
-        </p:spPr>
-        <p:txBody>
-          <a:bodyPr wrap="square" rtlCol="0" anchor="ctr"/>
-          <a:lstStyle/>
-          <a:p>
-            <a:pPr indent="0" marL="0">
-              <a:buNone/>
-            </a:pPr>
-            <a:r>
-              <a:rPr lang="en-US" sz="750" dirty="0">
-                <a:solidFill>
-                  <a:srgbClr val="AAAAAA"/>
-                </a:solidFill>
-                <a:latin typeface="Arial" pitchFamily="34" charset="0"/>
-                <a:ea typeface="Arial" pitchFamily="34" charset="-122"/>
-                <a:cs typeface="Arial" pitchFamily="34" charset="-120"/>
-              </a:rPr>
-              <a:t>Lesson Forge Pro (owner) — This content is educational material only and does not constitute financial, investment, or trading advice.</a:t>
-            </a:r>
-            <a:endParaRPr lang="en-US" sz="750" dirty="0"/>
-          </a:p>
-        </p:txBody>
-      </p:sp>
-      <p:sp>
-        <p:nvSpPr>
-          <p:cNvPr id="6" name="Shape 4"/>
-          <p:cNvSpPr/>
-          <p:nvPr/>
-        </p:nvSpPr>
-        <p:spPr>
-          <a:xfrm>
-            <a:off x="2011680" y="1234440"/>
-            <a:ext cx="5120640" cy="3108960"/>
-          </a:xfrm>
-          <a:prstGeom prst="rect">
-            <a:avLst/>
-          </a:prstGeom>
-          <a:solidFill>
-            <a:srgbClr val="FFFFFF"/>
-          </a:solidFill>
-          <a:ln w="15240">
+              <a:t>Assembling the Full DCF Model and Deriving Equity Value</a:t>
+            </a:r>
+            <a:endParaRPr lang="en-US" sz="2100" dirty="0"/>
+          </a:p>
+        </p:txBody>
+      </p:sp>
+      <p:sp>
+        <p:nvSpPr>
+          <p:cNvPr id="4" name="Shape 2"/>
+          <p:cNvSpPr/>
+          <p:nvPr/>
+        </p:nvSpPr>
+        <p:spPr>
+          <a:xfrm>
+            <a:off x="411480" y="960120"/>
+            <a:ext cx="8321040" cy="0"/>
+          </a:xfrm>
+          <a:prstGeom prst="line">
+            <a:avLst/>
+          </a:prstGeom>
+          <a:noFill/>
+          <a:ln w="12700">
             <a:solidFill>
-              <a:srgbClr val="1C1917"/>
+              <a:srgbClr val="E7E5E4"/>
             </a:solidFill>
             <a:prstDash val="solid"/>
           </a:ln>
@@ -6343,22 +6746,194 @@
       </p:sp>
       <p:sp>
         <p:nvSpPr>
+          <p:cNvPr id="5" name="Text 3"/>
+          <p:cNvSpPr/>
+          <p:nvPr/>
+        </p:nvSpPr>
+        <p:spPr>
+          <a:xfrm>
+            <a:off x="411480" y="4864608"/>
+            <a:ext cx="8321040" cy="237744"/>
+          </a:xfrm>
+          <a:prstGeom prst="rect">
+            <a:avLst/>
+          </a:prstGeom>
+          <a:noFill/>
+          <a:ln/>
+        </p:spPr>
+        <p:txBody>
+          <a:bodyPr wrap="square" rtlCol="0" anchor="ctr"/>
+          <a:lstStyle/>
+          <a:p>
+            <a:pPr indent="0" marL="0">
+              <a:buNone/>
+            </a:pPr>
+            <a:r>
+              <a:rPr lang="en-US" sz="750" dirty="0">
+                <a:solidFill>
+                  <a:srgbClr val="AAAAAA"/>
+                </a:solidFill>
+                <a:latin typeface="Arial" pitchFamily="34" charset="0"/>
+                <a:ea typeface="Arial" pitchFamily="34" charset="-122"/>
+                <a:cs typeface="Arial" pitchFamily="34" charset="-120"/>
+              </a:rPr>
+              <a:t>Lesson Forge Pro (owner) — This content is educational material only and does not constitute financial, investment, or trading advice.</a:t>
+            </a:r>
+            <a:endParaRPr lang="en-US" sz="750" dirty="0"/>
+          </a:p>
+        </p:txBody>
+      </p:sp>
+      <p:sp>
+        <p:nvSpPr>
+          <p:cNvPr id="6" name="Text 4"/>
+          <p:cNvSpPr/>
+          <p:nvPr/>
+        </p:nvSpPr>
+        <p:spPr>
+          <a:xfrm>
+            <a:off x="731520" y="1188720"/>
+            <a:ext cx="7680960" cy="2743200"/>
+          </a:xfrm>
+          <a:prstGeom prst="rect">
+            <a:avLst/>
+          </a:prstGeom>
+          <a:noFill/>
+          <a:ln/>
+        </p:spPr>
+        <p:txBody>
+          <a:bodyPr wrap="square" rtlCol="0" anchor="t"/>
+          <a:lstStyle/>
+          <a:p>
+            <a:pPr marL="152400" indent="-152400">
+              <a:spcAft>
+                <a:spcPts val="800"/>
+              </a:spcAft>
+              <a:buSzPct val="100000"/>
+              <a:buChar char="•"/>
+            </a:pPr>
+            <a:r>
+              <a:rPr lang="en-US" sz="1500" dirty="0">
+                <a:solidFill>
+                  <a:srgbClr val="1C1917"/>
+                </a:solidFill>
+                <a:latin typeface="Arial" pitchFamily="34" charset="0"/>
+                <a:ea typeface="Arial" pitchFamily="34" charset="-122"/>
+                <a:cs typeface="Arial" pitchFamily="34" charset="-120"/>
+              </a:rPr>
+              <a:t>Enterprise Value = PV of explicit-period FCFFs + PV of Terminal Value.</a:t>
+            </a:r>
+            <a:endParaRPr lang="en-US" sz="1500" dirty="0"/>
+          </a:p>
+          <a:p>
+            <a:pPr marL="152400" indent="-152400">
+              <a:spcAft>
+                <a:spcPts val="800"/>
+              </a:spcAft>
+              <a:buSzPct val="100000"/>
+              <a:buChar char="•"/>
+            </a:pPr>
+            <a:r>
+              <a:rPr lang="en-US" sz="1500" dirty="0">
+                <a:solidFill>
+                  <a:srgbClr val="1C1917"/>
+                </a:solidFill>
+                <a:latin typeface="Arial" pitchFamily="34" charset="0"/>
+                <a:ea typeface="Arial" pitchFamily="34" charset="-122"/>
+                <a:cs typeface="Arial" pitchFamily="34" charset="-120"/>
+              </a:rPr>
+              <a:t>Discount each year's FCFF and terminal value at WACC.</a:t>
+            </a:r>
+            <a:endParaRPr lang="en-US" sz="1500" dirty="0"/>
+          </a:p>
+          <a:p>
+            <a:pPr marL="152400" indent="-152400">
+              <a:spcAft>
+                <a:spcPts val="800"/>
+              </a:spcAft>
+              <a:buSzPct val="100000"/>
+              <a:buChar char="•"/>
+            </a:pPr>
+            <a:r>
+              <a:rPr lang="en-US" sz="1500" dirty="0">
+                <a:solidFill>
+                  <a:srgbClr val="1C1917"/>
+                </a:solidFill>
+                <a:latin typeface="Arial" pitchFamily="34" charset="0"/>
+                <a:ea typeface="Arial" pitchFamily="34" charset="-122"/>
+                <a:cs typeface="Arial" pitchFamily="34" charset="-120"/>
+              </a:rPr>
+              <a:t>Equity Value = Enterprise Value − Net Debt.</a:t>
+            </a:r>
+            <a:endParaRPr lang="en-US" sz="1500" dirty="0"/>
+          </a:p>
+          <a:p>
+            <a:pPr marL="152400" indent="-152400">
+              <a:spcAft>
+                <a:spcPts val="800"/>
+              </a:spcAft>
+              <a:buSzPct val="100000"/>
+              <a:buChar char="•"/>
+            </a:pPr>
+            <a:r>
+              <a:rPr lang="en-US" sz="1500" dirty="0">
+                <a:solidFill>
+                  <a:srgbClr val="1C1917"/>
+                </a:solidFill>
+                <a:latin typeface="Arial" pitchFamily="34" charset="0"/>
+                <a:ea typeface="Arial" pitchFamily="34" charset="-122"/>
+                <a:cs typeface="Arial" pitchFamily="34" charset="-120"/>
+              </a:rPr>
+              <a:t>Divide Equity Value by diluted shares outstanding for intrinsic price per share.</a:t>
+            </a:r>
+            <a:endParaRPr lang="en-US" sz="1500" dirty="0"/>
+          </a:p>
+          <a:p>
+            <a:pPr marL="152400" indent="-152400">
+              <a:spcAft>
+                <a:spcPts val="800"/>
+              </a:spcAft>
+              <a:buSzPct val="100000"/>
+              <a:buChar char="•"/>
+            </a:pPr>
+            <a:r>
+              <a:rPr lang="en-US" sz="1500" dirty="0">
+                <a:solidFill>
+                  <a:srgbClr val="1C1917"/>
+                </a:solidFill>
+                <a:latin typeface="Arial" pitchFamily="34" charset="0"/>
+                <a:ea typeface="Arial" pitchFamily="34" charset="-122"/>
+                <a:cs typeface="Arial" pitchFamily="34" charset="-120"/>
+              </a:rPr>
+              <a:t>Keep the model modular so assumptions are easy to audit and update.</a:t>
+            </a:r>
+            <a:endParaRPr lang="en-US" sz="1500" dirty="0"/>
+          </a:p>
+        </p:txBody>
+      </p:sp>
+      <p:sp>
+        <p:nvSpPr>
           <p:cNvPr id="7" name="Shape 5"/>
           <p:cNvSpPr/>
           <p:nvPr/>
         </p:nvSpPr>
         <p:spPr>
           <a:xfrm>
-            <a:off x="4572000" y="1234440"/>
-            <a:ext cx="0" cy="3108960"/>
-          </a:xfrm>
-          <a:prstGeom prst="line">
-            <a:avLst/>
-          </a:prstGeom>
-          <a:noFill/>
-          <a:ln w="11430">
+            <a:off x="731520" y="4041648"/>
+            <a:ext cx="7680960" cy="566928"/>
+          </a:xfrm>
+          <a:prstGeom prst="roundRect">
+            <a:avLst>
+              <a:gd name="adj" fmla="val 12903"/>
+            </a:avLst>
+          </a:prstGeom>
+          <a:solidFill>
+            <a:srgbClr val="B45309">
+              <a:alpha val="12000"/>
+            </a:srgbClr>
+          </a:solidFill>
+          <a:ln w="12700">
             <a:solidFill>
-              <a:srgbClr val="1C1917"/>
+              <a:srgbClr val="B45309"/>
             </a:solidFill>
             <a:prstDash val="solid"/>
           </a:ln>
@@ -6366,61 +6941,14 @@
       </p:sp>
       <p:sp>
         <p:nvSpPr>
-          <p:cNvPr id="8" name="Shape 6"/>
-          <p:cNvSpPr/>
-          <p:nvPr/>
-        </p:nvSpPr>
-        <p:spPr>
-          <a:xfrm>
-            <a:off x="2011680" y="2788920"/>
-            <a:ext cx="5120640" cy="0"/>
-          </a:xfrm>
-          <a:prstGeom prst="line">
-            <a:avLst/>
-          </a:prstGeom>
-          <a:noFill/>
-          <a:ln w="11430">
-            <a:solidFill>
-              <a:srgbClr val="1C1917"/>
-            </a:solidFill>
-            <a:prstDash val="solid"/>
-          </a:ln>
-        </p:spPr>
-      </p:sp>
-      <p:sp>
-        <p:nvSpPr>
-          <p:cNvPr id="9" name="Shape 7"/>
-          <p:cNvSpPr/>
-          <p:nvPr/>
-        </p:nvSpPr>
-        <p:spPr>
-          <a:xfrm>
-            <a:off x="2240280" y="1600200"/>
-            <a:ext cx="2103120" cy="822960"/>
-          </a:xfrm>
-          <a:prstGeom prst="roundRect">
-            <a:avLst>
-              <a:gd name="adj" fmla="val 11111"/>
-            </a:avLst>
-          </a:prstGeom>
-          <a:solidFill>
-            <a:srgbClr val="B45309">
-              <a:alpha val="15000"/>
-            </a:srgbClr>
-          </a:solidFill>
-          <a:ln/>
-        </p:spPr>
-      </p:sp>
-      <p:sp>
-        <p:nvSpPr>
-          <p:cNvPr id="10" name="Text 8"/>
-          <p:cNvSpPr/>
-          <p:nvPr/>
-        </p:nvSpPr>
-        <p:spPr>
-          <a:xfrm>
-            <a:off x="2240280" y="1600200"/>
-            <a:ext cx="2103120" cy="822960"/>
+          <p:cNvPr id="8" name="Text 6"/>
+          <p:cNvSpPr/>
+          <p:nvPr/>
+        </p:nvSpPr>
+        <p:spPr>
+          <a:xfrm>
+            <a:off x="868680" y="4087368"/>
+            <a:ext cx="7406640" cy="475488"/>
           </a:xfrm>
           <a:prstGeom prst="rect">
             <a:avLst/>
@@ -6432,11 +6960,25 @@
           <a:bodyPr wrap="square" rtlCol="0" anchor="ctr"/>
           <a:lstStyle/>
           <a:p>
-            <a:pPr algn="ctr" indent="0" marL="0">
-              <a:buNone/>
-            </a:pPr>
-            <a:r>
-              <a:rPr lang="en-US" sz="1200" b="1" dirty="0">
+            <a:pPr indent="0" marL="0">
+              <a:buNone/>
+            </a:pPr>
+            <a:r>
+              <a:rPr lang="en-US" sz="1100" b="1" dirty="0">
+                <a:solidFill>
+                  <a:srgbClr val="B45309"/>
+                </a:solidFill>
+                <a:latin typeface="Arial" pitchFamily="34" charset="0"/>
+                <a:ea typeface="Arial" pitchFamily="34" charset="-122"/>
+                <a:cs typeface="Arial" pitchFamily="34" charset="-120"/>
+              </a:rPr>
+              <a:t>Takeaway  </a:t>
+            </a:r>
+            <a:pPr indent="0" marL="0">
+              <a:buNone/>
+            </a:pPr>
+            <a:r>
+              <a:rPr lang="en-US" sz="1150" dirty="0">
                 <a:solidFill>
                   <a:srgbClr val="1C1917"/>
                 </a:solidFill>
@@ -6444,422 +6986,9 @@
                 <a:ea typeface="Arial" pitchFamily="34" charset="-122"/>
                 <a:cs typeface="Arial" pitchFamily="34" charset="-120"/>
               </a:rPr>
-              <a:t>Primary DCF Tool</a:t>
-            </a:r>
-            <a:endParaRPr lang="en-US" sz="1200" dirty="0"/>
-          </a:p>
-          <a:p>
-            <a:pPr algn="ctr" indent="0" marL="0">
-              <a:buNone/>
-            </a:pPr>
-            <a:r>
-              <a:rPr lang="en-US" sz="900" dirty="0">
-                <a:solidFill>
-                  <a:srgbClr val="78716C"/>
-                </a:solidFill>
-                <a:latin typeface="Arial" pitchFamily="34" charset="0"/>
-                <a:ea typeface="Arial" pitchFamily="34" charset="-122"/>
-                <a:cs typeface="Arial" pitchFamily="34" charset="-120"/>
-              </a:rPr>
-              <a:t>High risk, scarce comps: private firms, novel projects</a:t>
-            </a:r>
-            <a:endParaRPr lang="en-US" sz="1200" dirty="0"/>
-          </a:p>
-        </p:txBody>
-      </p:sp>
-      <p:sp>
-        <p:nvSpPr>
-          <p:cNvPr id="11" name="Shape 9"/>
-          <p:cNvSpPr/>
-          <p:nvPr/>
-        </p:nvSpPr>
-        <p:spPr>
-          <a:xfrm>
-            <a:off x="4800600" y="1600200"/>
-            <a:ext cx="2103120" cy="822960"/>
-          </a:xfrm>
-          <a:prstGeom prst="roundRect">
-            <a:avLst>
-              <a:gd name="adj" fmla="val 11111"/>
-            </a:avLst>
-          </a:prstGeom>
-          <a:solidFill>
-            <a:srgbClr val="B45309">
-              <a:alpha val="15000"/>
-            </a:srgbClr>
-          </a:solidFill>
-          <a:ln/>
-        </p:spPr>
-      </p:sp>
-      <p:sp>
-        <p:nvSpPr>
-          <p:cNvPr id="12" name="Text 10"/>
-          <p:cNvSpPr/>
-          <p:nvPr/>
-        </p:nvSpPr>
-        <p:spPr>
-          <a:xfrm>
-            <a:off x="4800600" y="1600200"/>
-            <a:ext cx="2103120" cy="822960"/>
-          </a:xfrm>
-          <a:prstGeom prst="rect">
-            <a:avLst/>
-          </a:prstGeom>
-          <a:noFill/>
-          <a:ln/>
-        </p:spPr>
-        <p:txBody>
-          <a:bodyPr wrap="square" rtlCol="0" anchor="ctr"/>
-          <a:lstStyle/>
-          <a:p>
-            <a:pPr algn="ctr" indent="0" marL="0">
-              <a:buNone/>
-            </a:pPr>
-            <a:r>
-              <a:rPr lang="en-US" sz="1200" b="1" dirty="0">
-                <a:solidFill>
-                  <a:srgbClr val="1C1917"/>
-                </a:solidFill>
-                <a:latin typeface="Arial" pitchFamily="34" charset="0"/>
-                <a:ea typeface="Arial" pitchFamily="34" charset="-122"/>
-                <a:cs typeface="Arial" pitchFamily="34" charset="-120"/>
-              </a:rPr>
-              <a:t>DCF + Market Cross-Check</a:t>
-            </a:r>
-            <a:endParaRPr lang="en-US" sz="1200" dirty="0"/>
-          </a:p>
-          <a:p>
-            <a:pPr algn="ctr" indent="0" marL="0">
-              <a:buNone/>
-            </a:pPr>
-            <a:r>
-              <a:rPr lang="en-US" sz="900" dirty="0">
-                <a:solidFill>
-                  <a:srgbClr val="78716C"/>
-                </a:solidFill>
-                <a:latin typeface="Arial" pitchFamily="34" charset="0"/>
-                <a:ea typeface="Arial" pitchFamily="34" charset="-122"/>
-                <a:cs typeface="Arial" pitchFamily="34" charset="-120"/>
-              </a:rPr>
-              <a:t>High risk, rich comps: distressed public companies</a:t>
-            </a:r>
-            <a:endParaRPr lang="en-US" sz="1200" dirty="0"/>
-          </a:p>
-        </p:txBody>
-      </p:sp>
-      <p:sp>
-        <p:nvSpPr>
-          <p:cNvPr id="13" name="Shape 11"/>
-          <p:cNvSpPr/>
-          <p:nvPr/>
-        </p:nvSpPr>
-        <p:spPr>
-          <a:xfrm>
-            <a:off x="2240280" y="3154680"/>
-            <a:ext cx="2103120" cy="822960"/>
-          </a:xfrm>
-          <a:prstGeom prst="roundRect">
-            <a:avLst>
-              <a:gd name="adj" fmla="val 11111"/>
-            </a:avLst>
-          </a:prstGeom>
-          <a:solidFill>
-            <a:srgbClr val="B45309">
-              <a:alpha val="15000"/>
-            </a:srgbClr>
-          </a:solidFill>
-          <a:ln/>
-        </p:spPr>
-      </p:sp>
-      <p:sp>
-        <p:nvSpPr>
-          <p:cNvPr id="14" name="Text 12"/>
-          <p:cNvSpPr/>
-          <p:nvPr/>
-        </p:nvSpPr>
-        <p:spPr>
-          <a:xfrm>
-            <a:off x="2240280" y="3154680"/>
-            <a:ext cx="2103120" cy="822960"/>
-          </a:xfrm>
-          <a:prstGeom prst="rect">
-            <a:avLst/>
-          </a:prstGeom>
-          <a:noFill/>
-          <a:ln/>
-        </p:spPr>
-        <p:txBody>
-          <a:bodyPr wrap="square" rtlCol="0" anchor="ctr"/>
-          <a:lstStyle/>
-          <a:p>
-            <a:pPr algn="ctr" indent="0" marL="0">
-              <a:buNone/>
-            </a:pPr>
-            <a:r>
-              <a:rPr lang="en-US" sz="1200" b="1" dirty="0">
-                <a:solidFill>
-                  <a:srgbClr val="1C1917"/>
-                </a:solidFill>
-                <a:latin typeface="Arial" pitchFamily="34" charset="0"/>
-                <a:ea typeface="Arial" pitchFamily="34" charset="-122"/>
-                <a:cs typeface="Arial" pitchFamily="34" charset="-120"/>
-              </a:rPr>
-              <a:t>DCF as Sanity Check</a:t>
-            </a:r>
-            <a:endParaRPr lang="en-US" sz="1200" dirty="0"/>
-          </a:p>
-          <a:p>
-            <a:pPr algn="ctr" indent="0" marL="0">
-              <a:buNone/>
-            </a:pPr>
-            <a:r>
-              <a:rPr lang="en-US" sz="900" dirty="0">
-                <a:solidFill>
-                  <a:srgbClr val="78716C"/>
-                </a:solidFill>
-                <a:latin typeface="Arial" pitchFamily="34" charset="0"/>
-                <a:ea typeface="Arial" pitchFamily="34" charset="-122"/>
-                <a:cs typeface="Arial" pitchFamily="34" charset="-120"/>
-              </a:rPr>
-              <a:t>Low risk, scarce comps: stable private assets</a:t>
-            </a:r>
-            <a:endParaRPr lang="en-US" sz="1200" dirty="0"/>
-          </a:p>
-        </p:txBody>
-      </p:sp>
-      <p:sp>
-        <p:nvSpPr>
-          <p:cNvPr id="15" name="Shape 13"/>
-          <p:cNvSpPr/>
-          <p:nvPr/>
-        </p:nvSpPr>
-        <p:spPr>
-          <a:xfrm>
-            <a:off x="4800600" y="3154680"/>
-            <a:ext cx="2103120" cy="822960"/>
-          </a:xfrm>
-          <a:prstGeom prst="roundRect">
-            <a:avLst>
-              <a:gd name="adj" fmla="val 11111"/>
-            </a:avLst>
-          </a:prstGeom>
-          <a:solidFill>
-            <a:srgbClr val="B45309">
-              <a:alpha val="15000"/>
-            </a:srgbClr>
-          </a:solidFill>
-          <a:ln/>
-        </p:spPr>
-      </p:sp>
-      <p:sp>
-        <p:nvSpPr>
-          <p:cNvPr id="16" name="Text 14"/>
-          <p:cNvSpPr/>
-          <p:nvPr/>
-        </p:nvSpPr>
-        <p:spPr>
-          <a:xfrm>
-            <a:off x="4800600" y="3154680"/>
-            <a:ext cx="2103120" cy="822960"/>
-          </a:xfrm>
-          <a:prstGeom prst="rect">
-            <a:avLst/>
-          </a:prstGeom>
-          <a:noFill/>
-          <a:ln/>
-        </p:spPr>
-        <p:txBody>
-          <a:bodyPr wrap="square" rtlCol="0" anchor="ctr"/>
-          <a:lstStyle/>
-          <a:p>
-            <a:pPr algn="ctr" indent="0" marL="0">
-              <a:buNone/>
-            </a:pPr>
-            <a:r>
-              <a:rPr lang="en-US" sz="1200" b="1" dirty="0">
-                <a:solidFill>
-                  <a:srgbClr val="1C1917"/>
-                </a:solidFill>
-                <a:latin typeface="Arial" pitchFamily="34" charset="0"/>
-                <a:ea typeface="Arial" pitchFamily="34" charset="-122"/>
-                <a:cs typeface="Arial" pitchFamily="34" charset="-120"/>
-              </a:rPr>
-              <a:t>Market Approach Preferred</a:t>
-            </a:r>
-            <a:endParaRPr lang="en-US" sz="1200" dirty="0"/>
-          </a:p>
-          <a:p>
-            <a:pPr algn="ctr" indent="0" marL="0">
-              <a:buNone/>
-            </a:pPr>
-            <a:r>
-              <a:rPr lang="en-US" sz="900" dirty="0">
-                <a:solidFill>
-                  <a:srgbClr val="78716C"/>
-                </a:solidFill>
-                <a:latin typeface="Arial" pitchFamily="34" charset="0"/>
-                <a:ea typeface="Arial" pitchFamily="34" charset="-122"/>
-                <a:cs typeface="Arial" pitchFamily="34" charset="-120"/>
-              </a:rPr>
-              <a:t>Low risk, rich comps: liquid public equities</a:t>
-            </a:r>
-            <a:endParaRPr lang="en-US" sz="1200" dirty="0"/>
-          </a:p>
-        </p:txBody>
-      </p:sp>
-      <p:sp>
-        <p:nvSpPr>
-          <p:cNvPr id="17" name="Text 15"/>
-          <p:cNvSpPr/>
-          <p:nvPr/>
-        </p:nvSpPr>
-        <p:spPr>
-          <a:xfrm>
-            <a:off x="1920240" y="4398264"/>
-            <a:ext cx="2194560" cy="274320"/>
-          </a:xfrm>
-          <a:prstGeom prst="rect">
-            <a:avLst/>
-          </a:prstGeom>
-          <a:noFill/>
-          <a:ln/>
-        </p:spPr>
-        <p:txBody>
-          <a:bodyPr wrap="square" rtlCol="0" anchor="ctr"/>
-          <a:lstStyle/>
-          <a:p>
-            <a:pPr indent="0" marL="0">
-              <a:buNone/>
-            </a:pPr>
-            <a:r>
-              <a:rPr lang="en-US" sz="950" dirty="0">
-                <a:solidFill>
-                  <a:srgbClr val="78716C"/>
-                </a:solidFill>
-                <a:latin typeface="Arial" pitchFamily="34" charset="0"/>
-                <a:ea typeface="Arial" pitchFamily="34" charset="-122"/>
-                <a:cs typeface="Arial" pitchFamily="34" charset="-120"/>
-              </a:rPr>
-              <a:t>Scarce Market Data</a:t>
-            </a:r>
-            <a:endParaRPr lang="en-US" sz="950" dirty="0"/>
-          </a:p>
-        </p:txBody>
-      </p:sp>
-      <p:sp>
-        <p:nvSpPr>
-          <p:cNvPr id="18" name="Text 16"/>
-          <p:cNvSpPr/>
-          <p:nvPr/>
-        </p:nvSpPr>
-        <p:spPr>
-          <a:xfrm>
-            <a:off x="5029200" y="4398264"/>
-            <a:ext cx="2194560" cy="274320"/>
-          </a:xfrm>
-          <a:prstGeom prst="rect">
-            <a:avLst/>
-          </a:prstGeom>
-          <a:noFill/>
-          <a:ln/>
-        </p:spPr>
-        <p:txBody>
-          <a:bodyPr wrap="square" rtlCol="0" anchor="ctr"/>
-          <a:lstStyle/>
-          <a:p>
-            <a:pPr algn="r" indent="0" marL="0">
-              <a:buNone/>
-            </a:pPr>
-            <a:r>
-              <a:rPr lang="en-US" sz="950" dirty="0">
-                <a:solidFill>
-                  <a:srgbClr val="78716C"/>
-                </a:solidFill>
-                <a:latin typeface="Arial" pitchFamily="34" charset="0"/>
-                <a:ea typeface="Arial" pitchFamily="34" charset="-122"/>
-                <a:cs typeface="Arial" pitchFamily="34" charset="-120"/>
-              </a:rPr>
-              <a:t>Rich Market Data</a:t>
-            </a:r>
-            <a:endParaRPr lang="en-US" sz="950" dirty="0"/>
-          </a:p>
-        </p:txBody>
-      </p:sp>
-      <p:sp>
-        <p:nvSpPr>
-          <p:cNvPr id="19" name="Text 17"/>
-          <p:cNvSpPr/>
-          <p:nvPr/>
-        </p:nvSpPr>
-        <p:spPr>
-          <a:xfrm>
-            <a:off x="45720" y="1280160"/>
-            <a:ext cx="1828800" cy="274320"/>
-          </a:xfrm>
-          <a:prstGeom prst="rect">
-            <a:avLst/>
-          </a:prstGeom>
-          <a:noFill/>
-          <a:ln/>
-        </p:spPr>
-        <p:txBody>
-          <a:bodyPr wrap="square" rtlCol="0" anchor="ctr"/>
-          <a:lstStyle/>
-          <a:p>
-            <a:pPr algn="r" indent="0" marL="0">
-              <a:buNone/>
-            </a:pPr>
-            <a:r>
-              <a:rPr lang="en-US" sz="950" dirty="0">
-                <a:solidFill>
-                  <a:srgbClr val="78716C"/>
-                </a:solidFill>
-                <a:latin typeface="Arial" pitchFamily="34" charset="0"/>
-                <a:ea typeface="Arial" pitchFamily="34" charset="-122"/>
-                <a:cs typeface="Arial" pitchFamily="34" charset="-120"/>
-              </a:rPr>
-              <a:t>Higher Risk</a:t>
-            </a:r>
-            <a:endParaRPr lang="en-US" sz="950" dirty="0"/>
-          </a:p>
-        </p:txBody>
-      </p:sp>
-      <p:sp>
-        <p:nvSpPr>
-          <p:cNvPr id="20" name="Text 18"/>
-          <p:cNvSpPr/>
-          <p:nvPr/>
-        </p:nvSpPr>
-        <p:spPr>
-          <a:xfrm>
-            <a:off x="45720" y="4023360"/>
-            <a:ext cx="1828800" cy="274320"/>
-          </a:xfrm>
-          <a:prstGeom prst="rect">
-            <a:avLst/>
-          </a:prstGeom>
-          <a:noFill/>
-          <a:ln/>
-        </p:spPr>
-        <p:txBody>
-          <a:bodyPr wrap="square" rtlCol="0" anchor="ctr"/>
-          <a:lstStyle/>
-          <a:p>
-            <a:pPr algn="r" indent="0" marL="0">
-              <a:buNone/>
-            </a:pPr>
-            <a:r>
-              <a:rPr lang="en-US" sz="950" dirty="0">
-                <a:solidFill>
-                  <a:srgbClr val="78716C"/>
-                </a:solidFill>
-                <a:latin typeface="Arial" pitchFamily="34" charset="0"/>
-                <a:ea typeface="Arial" pitchFamily="34" charset="-122"/>
-                <a:cs typeface="Arial" pitchFamily="34" charset="-120"/>
-              </a:rPr>
-              <a:t>Lower Risk</a:t>
-            </a:r>
-            <a:endParaRPr lang="en-US" sz="950" dirty="0"/>
+              <a:t>Assembling a DCF is a disciplined chain from projected cash flows to a per-share intrinsic value, with every link traceable.</a:t>
+            </a:r>
+            <a:endParaRPr lang="en-US" sz="1100" dirty="0"/>
           </a:p>
         </p:txBody>
       </p:sp>

</xml_diff>